<commit_message>
Day 1 afternoon accessible: convert 14 OLE equations to text; fix 10 Symbol PUA chars
Co-Authored-By: Claude Opus 4.8 <noreply@anthropic.com>
</commit_message>
<xml_diff>
--- a/Day1_Probability/FW536_Day1_Afternoon Distributions I_accessible.pptx
+++ b/Day1_Probability/FW536_Day1_Afternoon Distributions I_accessible.pptx
@@ -7793,91 +7793,6 @@
           </a:p>
         </p:txBody>
       </p:sp>
-      <p:graphicFrame>
-        <p:nvGraphicFramePr>
-          <p:cNvPr id="149508" name="Object 9"/>
-          <p:cNvGraphicFramePr>
-            <a:graphicFrameLocks noGrp="1" noChangeAspect="1"/>
-          </p:cNvGraphicFramePr>
-          <p:nvPr>
-            <p:ph sz="quarter" idx="3"/>
-          </p:nvPr>
-        </p:nvGraphicFramePr>
-        <p:xfrm>
-          <a:off x="4924425" y="4114800"/>
-          <a:ext cx="2514600" cy="914400"/>
-        </p:xfrm>
-        <a:graphic>
-          <a:graphicData uri="http://schemas.openxmlformats.org/presentationml/2006/ole">
-            <mc:AlternateContent xmlns:mc="http://schemas.openxmlformats.org/markup-compatibility/2006">
-              <mc:Choice xmlns:v="urn:schemas-microsoft-com:vml" Requires="v">
-                <p:oleObj name="Equation" r:id="rId3" imgW="1257231" imgH="456924" progId="">
-                  <p:embed/>
-                </p:oleObj>
-              </mc:Choice>
-              <mc:Fallback>
-                <p:oleObj name="Equation" r:id="rId3" imgW="1257231" imgH="456924" progId="">
-                  <p:embed/>
-                  <p:pic>
-                    <p:nvPicPr>
-                      <p:cNvPr id="0" name=""/>
-                      <p:cNvPicPr>
-                        <a:picLocks noGrp="1" noChangeAspect="1" noChangeArrowheads="1"/>
-                      </p:cNvPicPr>
-                      <p:nvPr/>
-                    </p:nvPicPr>
-                    <p:blipFill>
-                      <a:blip r:embed="rId4">
-                        <a:extLst>
-                          <a:ext uri="{28A0092B-C50C-407E-A947-70E740481C1C}">
-                            <a14:useLocalDpi xmlns:a14="http://schemas.microsoft.com/office/drawing/2010/main" val="0"/>
-                          </a:ext>
-                        </a:extLst>
-                      </a:blip>
-                      <a:srcRect/>
-                      <a:stretch>
-                        <a:fillRect/>
-                      </a:stretch>
-                    </p:blipFill>
-                    <p:spPr bwMode="auto">
-                      <a:xfrm>
-                        <a:off x="4924425" y="4114800"/>
-                        <a:ext cx="2514600" cy="914400"/>
-                      </a:xfrm>
-                      <a:prstGeom prst="rect">
-                        <a:avLst/>
-                      </a:prstGeom>
-                      <a:noFill/>
-                      <a:ln>
-                        <a:noFill/>
-                      </a:ln>
-                      <a:extLst>
-                        <a:ext uri="{909E8E84-426E-40DD-AFC4-6F175D3DCCD1}">
-                          <a14:hiddenFill xmlns:a14="http://schemas.microsoft.com/office/drawing/2010/main">
-                            <a:solidFill>
-                              <a:srgbClr val="FFFFFF"/>
-                            </a:solidFill>
-                          </a14:hiddenFill>
-                        </a:ext>
-                        <a:ext uri="{91240B29-F687-4F45-9708-019B960494DF}">
-                          <a14:hiddenLine xmlns:a14="http://schemas.microsoft.com/office/drawing/2010/main" w="9525">
-                            <a:solidFill>
-                              <a:schemeClr val="tx1"/>
-                            </a:solidFill>
-                            <a:miter lim="800000"/>
-                            <a:headEnd/>
-                            <a:tailEnd/>
-                          </a14:hiddenLine>
-                        </a:ext>
-                      </a:extLst>
-                    </p:spPr>
-                  </p:pic>
-                </p:oleObj>
-              </mc:Fallback>
-            </mc:AlternateContent>
-          </a:graphicData>
-        </a:graphic>
-      </p:graphicFrame>
       <p:sp>
         <p:nvSpPr>
           <p:cNvPr id="6" name="TextBox 5"/>
@@ -7972,6 +7887,57 @@
               <a:t>)</a:t>
             </a:r>
             <a:endParaRPr lang="en-US" sz="2800" i="1" dirty="0"/>
+          </a:p>
+        </p:txBody>
+      </p:sp>
+      <p:sp>
+        <p:nvSpPr>
+          <p:cNvPr id="8196" name="TextBox 8195"/>
+          <p:cNvSpPr txBox="1"/>
+          <p:nvPr/>
+        </p:nvSpPr>
+        <p:spPr>
+          <a:xfrm>
+            <a:off x="4924425" y="4114800"/>
+            <a:ext cx="2514600" cy="914400"/>
+          </a:xfrm>
+          <a:prstGeom prst="rect">
+            <a:avLst/>
+          </a:prstGeom>
+          <a:noFill/>
+        </p:spPr>
+        <p:txBody>
+          <a:bodyPr wrap="square" anchor="ctr" lIns="0" rIns="0" tIns="0" bIns="0">
+            <a:spAutoFit/>
+          </a:bodyPr>
+          <a:lstStyle/>
+          <a:p>
+            <a:r>
+              <a:rPr sz="1800">
+                <a:latin typeface="Cambria"/>
+              </a:rPr>
+              <a:t>Mean : μ = n p</a:t>
+            </a:r>
+          </a:p>
+          <a:p>
+            <a:r>
+              <a:rPr sz="1800">
+                <a:latin typeface="Cambria"/>
+              </a:rPr>
+              <a:t>Variance : σ</a:t>
+            </a:r>
+            <a:r>
+              <a:rPr sz="1800" baseline="30000">
+                <a:latin typeface="Cambria"/>
+              </a:rPr>
+              <a:t>2</a:t>
+            </a:r>
+            <a:r>
+              <a:rPr sz="1800">
+                <a:latin typeface="Cambria"/>
+              </a:rPr>
+              <a:t> = npq</a:t>
+            </a:r>
           </a:p>
         </p:txBody>
       </p:sp>
@@ -9199,95 +9165,6 @@
           </a:p>
         </p:txBody>
       </p:sp>
-      <p:graphicFrame>
-        <p:nvGraphicFramePr>
-          <p:cNvPr id="157699" name="Object 4"/>
-          <p:cNvGraphicFramePr>
-            <a:graphicFrameLocks noChangeAspect="1"/>
-          </p:cNvGraphicFramePr>
-          <p:nvPr>
-            <p:extLst>
-              <p:ext uri="{D42A27DB-BD31-4B8C-83A1-F6EECF244321}">
-                <p14:modId xmlns:p14="http://schemas.microsoft.com/office/powerpoint/2010/main" val="1473999975"/>
-              </p:ext>
-            </p:extLst>
-          </p:nvPr>
-        </p:nvGraphicFramePr>
-        <p:xfrm>
-          <a:off x="3468130" y="4590536"/>
-          <a:ext cx="3810000" cy="690563"/>
-        </p:xfrm>
-        <a:graphic>
-          <a:graphicData uri="http://schemas.openxmlformats.org/presentationml/2006/ole">
-            <mc:AlternateContent xmlns:mc="http://schemas.openxmlformats.org/markup-compatibility/2006">
-              <mc:Choice xmlns:v="urn:schemas-microsoft-com:vml" Requires="v">
-                <p:oleObj name="Equation" r:id="rId3" imgW="2311078" imgH="418893" progId="">
-                  <p:embed/>
-                </p:oleObj>
-              </mc:Choice>
-              <mc:Fallback>
-                <p:oleObj name="Equation" r:id="rId3" imgW="2311078" imgH="418893" progId="">
-                  <p:embed/>
-                  <p:pic>
-                    <p:nvPicPr>
-                      <p:cNvPr id="0" name=""/>
-                      <p:cNvPicPr>
-                        <a:picLocks noChangeAspect="1" noChangeArrowheads="1"/>
-                      </p:cNvPicPr>
-                      <p:nvPr/>
-                    </p:nvPicPr>
-                    <p:blipFill>
-                      <a:blip r:embed="rId4">
-                        <a:extLst>
-                          <a:ext uri="{28A0092B-C50C-407E-A947-70E740481C1C}">
-                            <a14:useLocalDpi xmlns:a14="http://schemas.microsoft.com/office/drawing/2010/main" val="0"/>
-                          </a:ext>
-                        </a:extLst>
-                      </a:blip>
-                      <a:srcRect/>
-                      <a:stretch>
-                        <a:fillRect/>
-                      </a:stretch>
-                    </p:blipFill>
-                    <p:spPr bwMode="auto">
-                      <a:xfrm>
-                        <a:off x="3468130" y="4590536"/>
-                        <a:ext cx="3810000" cy="690563"/>
-                      </a:xfrm>
-                      <a:prstGeom prst="rect">
-                        <a:avLst/>
-                      </a:prstGeom>
-                      <a:noFill/>
-                      <a:ln>
-                        <a:noFill/>
-                      </a:ln>
-                      <a:extLst>
-                        <a:ext uri="{909E8E84-426E-40DD-AFC4-6F175D3DCCD1}">
-                          <a14:hiddenFill xmlns:a14="http://schemas.microsoft.com/office/drawing/2010/main">
-                            <a:solidFill>
-                              <a:srgbClr val="FFFFFF"/>
-                            </a:solidFill>
-                          </a14:hiddenFill>
-                        </a:ext>
-                        <a:ext uri="{91240B29-F687-4F45-9708-019B960494DF}">
-                          <a14:hiddenLine xmlns:a14="http://schemas.microsoft.com/office/drawing/2010/main" w="9525">
-                            <a:solidFill>
-                              <a:schemeClr val="tx1"/>
-                            </a:solidFill>
-                            <a:miter lim="800000"/>
-                            <a:headEnd/>
-                            <a:tailEnd/>
-                          </a14:hiddenLine>
-                        </a:ext>
-                      </a:extLst>
-                    </p:spPr>
-                  </p:pic>
-                </p:oleObj>
-              </mc:Fallback>
-            </mc:AlternateContent>
-          </a:graphicData>
-        </a:graphic>
-      </p:graphicFrame>
       <p:sp>
         <p:nvSpPr>
           <p:cNvPr id="2" name="TextBox 1">
@@ -9323,6 +9200,103 @@
                 </a:solidFill>
               </a:rPr>
               <a:t>Group Work</a:t>
+            </a:r>
+          </a:p>
+        </p:txBody>
+      </p:sp>
+      <p:sp>
+        <p:nvSpPr>
+          <p:cNvPr id="12292" name="TextBox 12291"/>
+          <p:cNvSpPr txBox="1"/>
+          <p:nvPr/>
+        </p:nvSpPr>
+        <p:spPr>
+          <a:xfrm>
+            <a:off x="3468130" y="4590536"/>
+            <a:ext cx="6893169" cy="690563"/>
+          </a:xfrm>
+          <a:prstGeom prst="rect">
+            <a:avLst/>
+          </a:prstGeom>
+          <a:noFill/>
+        </p:spPr>
+        <p:txBody>
+          <a:bodyPr wrap="square" anchor="ctr" lIns="0" rIns="0" tIns="0" bIns="0">
+            <a:spAutoFit/>
+          </a:bodyPr>
+          <a:lstStyle/>
+          <a:p>
+            <a:r>
+              <a:rPr sz="1900">
+                <a:latin typeface="Cambria"/>
+              </a:rPr>
+              <a:t>P(x) = </a:t>
+            </a:r>
+            <a:r>
+              <a:rPr sz="1900" baseline="-25000">
+                <a:latin typeface="Cambria"/>
+              </a:rPr>
+              <a:t>n</a:t>
+            </a:r>
+            <a:r>
+              <a:rPr sz="1900">
+                <a:latin typeface="Cambria"/>
+              </a:rPr>
+              <a:t>C</a:t>
+            </a:r>
+            <a:r>
+              <a:rPr sz="1900" baseline="-25000">
+                <a:latin typeface="Cambria"/>
+              </a:rPr>
+              <a:t>x</a:t>
+            </a:r>
+            <a:r>
+              <a:rPr sz="1900">
+                <a:latin typeface="Cambria"/>
+              </a:rPr>
+              <a:t> p</a:t>
+            </a:r>
+            <a:r>
+              <a:rPr sz="1900" baseline="30000">
+                <a:latin typeface="Cambria"/>
+              </a:rPr>
+              <a:t>x</a:t>
+            </a:r>
+            <a:r>
+              <a:rPr sz="1900">
+                <a:latin typeface="Cambria"/>
+              </a:rPr>
+              <a:t> q</a:t>
+            </a:r>
+            <a:r>
+              <a:rPr sz="1900" baseline="30000">
+                <a:latin typeface="Cambria"/>
+              </a:rPr>
+              <a:t>n−x</a:t>
+            </a:r>
+            <a:r>
+              <a:rPr sz="1900">
+                <a:latin typeface="Cambria"/>
+              </a:rPr>
+              <a:t> = n! / ((n − x)! x!) · p</a:t>
+            </a:r>
+            <a:r>
+              <a:rPr sz="1900" baseline="30000">
+                <a:latin typeface="Cambria"/>
+              </a:rPr>
+              <a:t>x</a:t>
+            </a:r>
+            <a:r>
+              <a:rPr sz="1900">
+                <a:latin typeface="Cambria"/>
+              </a:rPr>
+              <a:t> q</a:t>
+            </a:r>
+            <a:r>
+              <a:rPr sz="1900" baseline="30000">
+                <a:latin typeface="Cambria"/>
+              </a:rPr>
+              <a:t>n−x</a:t>
             </a:r>
           </a:p>
         </p:txBody>
@@ -9441,10 +9415,8 @@
               <a:t>P[X</a:t>
             </a:r>
             <a:r>
-              <a:rPr lang="en-US" sz="3000" dirty="0">
-                <a:sym typeface="Symbol" pitchFamily="18" charset="2"/>
-              </a:rPr>
-              <a:t>2]=1-P[X=0]-P[X=1]=0.3410</a:t>
+              <a:rPr lang="en-US" sz="3000" dirty="0"/>
+              <a:t>≥2]=1-P[X=0]-P[X=1]=0.3410</a:t>
             </a:r>
           </a:p>
           <a:p>
@@ -9455,176 +9427,6 @@
           </a:p>
         </p:txBody>
       </p:sp>
-      <p:graphicFrame>
-        <p:nvGraphicFramePr>
-          <p:cNvPr id="159747" name="Object 4"/>
-          <p:cNvGraphicFramePr>
-            <a:graphicFrameLocks noGrp="1" noChangeAspect="1"/>
-          </p:cNvGraphicFramePr>
-          <p:nvPr>
-            <p:ph sz="quarter" idx="2"/>
-          </p:nvPr>
-        </p:nvGraphicFramePr>
-        <p:xfrm>
-          <a:off x="5106988" y="1905000"/>
-          <a:ext cx="2019300" cy="649288"/>
-        </p:xfrm>
-        <a:graphic>
-          <a:graphicData uri="http://schemas.openxmlformats.org/presentationml/2006/ole">
-            <mc:AlternateContent xmlns:mc="http://schemas.openxmlformats.org/markup-compatibility/2006">
-              <mc:Choice xmlns:v="urn:schemas-microsoft-com:vml" Requires="v">
-                <p:oleObj name="Equation" r:id="rId3" imgW="1422890" imgH="457200" progId="">
-                  <p:embed/>
-                </p:oleObj>
-              </mc:Choice>
-              <mc:Fallback>
-                <p:oleObj name="Equation" r:id="rId3" imgW="1422890" imgH="457200" progId="">
-                  <p:embed/>
-                  <p:pic>
-                    <p:nvPicPr>
-                      <p:cNvPr id="0" name=""/>
-                      <p:cNvPicPr>
-                        <a:picLocks noGrp="1" noChangeAspect="1" noChangeArrowheads="1"/>
-                      </p:cNvPicPr>
-                      <p:nvPr/>
-                    </p:nvPicPr>
-                    <p:blipFill>
-                      <a:blip r:embed="rId4">
-                        <a:extLst>
-                          <a:ext uri="{28A0092B-C50C-407E-A947-70E740481C1C}">
-                            <a14:useLocalDpi xmlns:a14="http://schemas.microsoft.com/office/drawing/2010/main" val="0"/>
-                          </a:ext>
-                        </a:extLst>
-                      </a:blip>
-                      <a:srcRect/>
-                      <a:stretch>
-                        <a:fillRect/>
-                      </a:stretch>
-                    </p:blipFill>
-                    <p:spPr bwMode="auto">
-                      <a:xfrm>
-                        <a:off x="5106988" y="1905000"/>
-                        <a:ext cx="2019300" cy="649288"/>
-                      </a:xfrm>
-                      <a:prstGeom prst="rect">
-                        <a:avLst/>
-                      </a:prstGeom>
-                      <a:noFill/>
-                      <a:ln>
-                        <a:noFill/>
-                      </a:ln>
-                      <a:extLst>
-                        <a:ext uri="{909E8E84-426E-40DD-AFC4-6F175D3DCCD1}">
-                          <a14:hiddenFill xmlns:a14="http://schemas.microsoft.com/office/drawing/2010/main">
-                            <a:solidFill>
-                              <a:srgbClr val="FFFFFF"/>
-                            </a:solidFill>
-                          </a14:hiddenFill>
-                        </a:ext>
-                        <a:ext uri="{91240B29-F687-4F45-9708-019B960494DF}">
-                          <a14:hiddenLine xmlns:a14="http://schemas.microsoft.com/office/drawing/2010/main" w="9525">
-                            <a:solidFill>
-                              <a:schemeClr val="tx1"/>
-                            </a:solidFill>
-                            <a:miter lim="800000"/>
-                            <a:headEnd/>
-                            <a:tailEnd/>
-                          </a14:hiddenLine>
-                        </a:ext>
-                      </a:extLst>
-                    </p:spPr>
-                  </p:pic>
-                </p:oleObj>
-              </mc:Fallback>
-            </mc:AlternateContent>
-          </a:graphicData>
-        </a:graphic>
-      </p:graphicFrame>
-      <p:graphicFrame>
-        <p:nvGraphicFramePr>
-          <p:cNvPr id="159748" name="Object 6"/>
-          <p:cNvGraphicFramePr>
-            <a:graphicFrameLocks noGrp="1" noChangeAspect="1"/>
-          </p:cNvGraphicFramePr>
-          <p:nvPr>
-            <p:ph sz="quarter" idx="3"/>
-          </p:nvPr>
-        </p:nvGraphicFramePr>
-        <p:xfrm>
-          <a:off x="5106988" y="2514600"/>
-          <a:ext cx="2038350" cy="649288"/>
-        </p:xfrm>
-        <a:graphic>
-          <a:graphicData uri="http://schemas.openxmlformats.org/presentationml/2006/ole">
-            <mc:AlternateContent xmlns:mc="http://schemas.openxmlformats.org/markup-compatibility/2006">
-              <mc:Choice xmlns:v="urn:schemas-microsoft-com:vml" Requires="v">
-                <p:oleObj name="Equation" r:id="rId5" imgW="1435575" imgH="457200" progId="">
-                  <p:embed/>
-                </p:oleObj>
-              </mc:Choice>
-              <mc:Fallback>
-                <p:oleObj name="Equation" r:id="rId5" imgW="1435575" imgH="457200" progId="">
-                  <p:embed/>
-                  <p:pic>
-                    <p:nvPicPr>
-                      <p:cNvPr id="0" name=""/>
-                      <p:cNvPicPr>
-                        <a:picLocks noGrp="1" noChangeAspect="1" noChangeArrowheads="1"/>
-                      </p:cNvPicPr>
-                      <p:nvPr/>
-                    </p:nvPicPr>
-                    <p:blipFill>
-                      <a:blip r:embed="rId6">
-                        <a:extLst>
-                          <a:ext uri="{28A0092B-C50C-407E-A947-70E740481C1C}">
-                            <a14:useLocalDpi xmlns:a14="http://schemas.microsoft.com/office/drawing/2010/main" val="0"/>
-                          </a:ext>
-                        </a:extLst>
-                      </a:blip>
-                      <a:srcRect/>
-                      <a:stretch>
-                        <a:fillRect/>
-                      </a:stretch>
-                    </p:blipFill>
-                    <p:spPr bwMode="auto">
-                      <a:xfrm>
-                        <a:off x="5106988" y="2514600"/>
-                        <a:ext cx="2038350" cy="649288"/>
-                      </a:xfrm>
-                      <a:prstGeom prst="rect">
-                        <a:avLst/>
-                      </a:prstGeom>
-                      <a:noFill/>
-                      <a:ln>
-                        <a:noFill/>
-                      </a:ln>
-                      <a:extLst>
-                        <a:ext uri="{909E8E84-426E-40DD-AFC4-6F175D3DCCD1}">
-                          <a14:hiddenFill xmlns:a14="http://schemas.microsoft.com/office/drawing/2010/main">
-                            <a:solidFill>
-                              <a:srgbClr val="FFFFFF"/>
-                            </a:solidFill>
-                          </a14:hiddenFill>
-                        </a:ext>
-                        <a:ext uri="{91240B29-F687-4F45-9708-019B960494DF}">
-                          <a14:hiddenLine xmlns:a14="http://schemas.microsoft.com/office/drawing/2010/main" w="9525">
-                            <a:solidFill>
-                              <a:schemeClr val="tx1"/>
-                            </a:solidFill>
-                            <a:miter lim="800000"/>
-                            <a:headEnd/>
-                            <a:tailEnd/>
-                          </a14:hiddenLine>
-                        </a:ext>
-                      </a:extLst>
-                    </p:spPr>
-                  </p:pic>
-                </p:oleObj>
-              </mc:Fallback>
-            </mc:AlternateContent>
-          </a:graphicData>
-        </a:graphic>
-      </p:graphicFrame>
       <p:pic>
         <p:nvPicPr>
           <p:cNvPr id="2" name="Picture 1" descr="R console: 1-pbinom(1,12,0.1) returns 0.3409977, the probability of 2 or more diseased animals out of 12 when p=0.1." title="R console: 1-pbinom(1,12,0.1) returns 0.3409977, the probability of 2 or more di"/>
@@ -9733,6 +9535,116 @@
           </a:extLst>
         </p:spPr>
       </p:pic>
+      <p:sp>
+        <p:nvSpPr>
+          <p:cNvPr id="159749" name="TextBox 159748"/>
+          <p:cNvSpPr txBox="1"/>
+          <p:nvPr/>
+        </p:nvSpPr>
+        <p:spPr>
+          <a:xfrm>
+            <a:off x="5106988" y="1905000"/>
+            <a:ext cx="4642338" cy="649288"/>
+          </a:xfrm>
+          <a:prstGeom prst="rect">
+            <a:avLst/>
+          </a:prstGeom>
+          <a:noFill/>
+        </p:spPr>
+        <p:txBody>
+          <a:bodyPr wrap="square" anchor="ctr" lIns="0" rIns="0" tIns="0" bIns="0">
+            <a:spAutoFit/>
+          </a:bodyPr>
+          <a:lstStyle/>
+          <a:p>
+            <a:r>
+              <a:rPr sz="1900">
+                <a:latin typeface="Cambria"/>
+              </a:rPr>
+              <a:t>(12 choose 2) 0.1</a:t>
+            </a:r>
+            <a:r>
+              <a:rPr sz="1900" baseline="30000">
+                <a:latin typeface="Cambria"/>
+              </a:rPr>
+              <a:t>2</a:t>
+            </a:r>
+            <a:r>
+              <a:rPr sz="1900">
+                <a:latin typeface="Cambria"/>
+              </a:rPr>
+              <a:t> 0.9</a:t>
+            </a:r>
+            <a:r>
+              <a:rPr sz="1900" baseline="30000">
+                <a:latin typeface="Cambria"/>
+              </a:rPr>
+              <a:t>10</a:t>
+            </a:r>
+            <a:r>
+              <a:rPr sz="1900">
+                <a:latin typeface="Cambria"/>
+              </a:rPr>
+              <a:t> = 0.2301</a:t>
+            </a:r>
+          </a:p>
+        </p:txBody>
+      </p:sp>
+      <p:sp>
+        <p:nvSpPr>
+          <p:cNvPr id="159750" name="TextBox 159749"/>
+          <p:cNvSpPr txBox="1"/>
+          <p:nvPr/>
+        </p:nvSpPr>
+        <p:spPr>
+          <a:xfrm>
+            <a:off x="5106988" y="2514600"/>
+            <a:ext cx="4642338" cy="649288"/>
+          </a:xfrm>
+          <a:prstGeom prst="rect">
+            <a:avLst/>
+          </a:prstGeom>
+          <a:noFill/>
+        </p:spPr>
+        <p:txBody>
+          <a:bodyPr wrap="square" anchor="ctr" lIns="0" rIns="0" tIns="0" bIns="0">
+            <a:spAutoFit/>
+          </a:bodyPr>
+          <a:lstStyle/>
+          <a:p>
+            <a:r>
+              <a:rPr sz="1900">
+                <a:latin typeface="Cambria"/>
+              </a:rPr>
+              <a:t>(12 choose 0) 0.1</a:t>
+            </a:r>
+            <a:r>
+              <a:rPr sz="1900" baseline="30000">
+                <a:latin typeface="Cambria"/>
+              </a:rPr>
+              <a:t>0</a:t>
+            </a:r>
+            <a:r>
+              <a:rPr sz="1900">
+                <a:latin typeface="Cambria"/>
+              </a:rPr>
+              <a:t> 0.9</a:t>
+            </a:r>
+            <a:r>
+              <a:rPr sz="1900" baseline="30000">
+                <a:latin typeface="Cambria"/>
+              </a:rPr>
+              <a:t>12</a:t>
+            </a:r>
+            <a:r>
+              <a:rPr sz="1900">
+                <a:latin typeface="Cambria"/>
+              </a:rPr>
+              <a:t> = 0.2824</a:t>
+            </a:r>
+          </a:p>
+        </p:txBody>
+      </p:sp>
     </p:spTree>
     <p:extLst>
       <p:ext uri="{BB962C8B-B14F-4D97-AF65-F5344CB8AC3E}">
@@ -11076,10 +10988,8 @@
               <a:t>We usually work with the log-likelihood. Can you find that? </a:t>
             </a:r>
             <a:r>
-              <a:rPr lang="en-US" dirty="0">
-                <a:sym typeface="Wingdings"/>
-              </a:rPr>
-              <a:t> </a:t>
+              <a:rPr lang="en-US" dirty="0"/>
+              <a:t>→ </a:t>
             </a:r>
             <a:r>
               <a:rPr lang="en-US" dirty="0"/>
@@ -14193,140 +14103,6 @@
           </a:p>
         </p:txBody>
       </p:sp>
-      <p:graphicFrame>
-        <p:nvGraphicFramePr>
-          <p:cNvPr id="189443" name="Object 4"/>
-          <p:cNvGraphicFramePr>
-            <a:graphicFrameLocks noGrp="1" noChangeAspect="1"/>
-          </p:cNvGraphicFramePr>
-          <p:nvPr>
-            <p:ph sz="quarter" idx="2"/>
-          </p:nvPr>
-        </p:nvGraphicFramePr>
-        <p:xfrm>
-          <a:off x="4397471" y="2509997"/>
-          <a:ext cx="2054225" cy="728412"/>
-        </p:xfrm>
-        <a:graphic>
-          <a:graphicData uri="http://schemas.openxmlformats.org/presentationml/2006/ole">
-            <mc:AlternateContent xmlns:mc="http://schemas.openxmlformats.org/markup-compatibility/2006">
-              <mc:Choice xmlns:v="urn:schemas-microsoft-com:vml" Requires="v">
-                <p:oleObj name="Equation" r:id="rId3" imgW="1180588" imgH="418918" progId="Equation.DSMT4">
-                  <p:embed/>
-                </p:oleObj>
-              </mc:Choice>
-              <mc:Fallback>
-                <p:oleObj name="Equation" r:id="rId3" imgW="1180588" imgH="418918" progId="Equation.DSMT4">
-                  <p:embed/>
-                  <p:pic>
-                    <p:nvPicPr>
-                      <p:cNvPr id="0" name=""/>
-                      <p:cNvPicPr>
-                        <a:picLocks noChangeAspect="1" noChangeArrowheads="1"/>
-                      </p:cNvPicPr>
-                      <p:nvPr/>
-                    </p:nvPicPr>
-                    <p:blipFill>
-                      <a:blip r:embed="rId4">
-                        <a:extLst>
-                          <a:ext uri="{28A0092B-C50C-407E-A947-70E740481C1C}">
-                            <a14:useLocalDpi xmlns:a14="http://schemas.microsoft.com/office/drawing/2010/main" val="0"/>
-                          </a:ext>
-                        </a:extLst>
-                      </a:blip>
-                      <a:srcRect/>
-                      <a:stretch>
-                        <a:fillRect/>
-                      </a:stretch>
-                    </p:blipFill>
-                    <p:spPr bwMode="auto">
-                      <a:xfrm>
-                        <a:off x="4397471" y="2509997"/>
-                        <a:ext cx="2054225" cy="728412"/>
-                      </a:xfrm>
-                      <a:prstGeom prst="rect">
-                        <a:avLst/>
-                      </a:prstGeom>
-                      <a:noFill/>
-                      <a:ln>
-                        <a:noFill/>
-                      </a:ln>
-                      <a:effectLst/>
-                    </p:spPr>
-                  </p:pic>
-                </p:oleObj>
-              </mc:Fallback>
-            </mc:AlternateContent>
-          </a:graphicData>
-        </a:graphic>
-      </p:graphicFrame>
-      <p:graphicFrame>
-        <p:nvGraphicFramePr>
-          <p:cNvPr id="191492" name="Object 6"/>
-          <p:cNvGraphicFramePr>
-            <a:graphicFrameLocks noGrp="1" noChangeAspect="1"/>
-          </p:cNvGraphicFramePr>
-          <p:nvPr>
-            <p:ph sz="quarter" idx="3"/>
-          </p:nvPr>
-        </p:nvGraphicFramePr>
-        <p:xfrm>
-          <a:off x="4297990" y="4872555"/>
-          <a:ext cx="3616658" cy="947220"/>
-        </p:xfrm>
-        <a:graphic>
-          <a:graphicData uri="http://schemas.openxmlformats.org/presentationml/2006/ole">
-            <mc:AlternateContent xmlns:mc="http://schemas.openxmlformats.org/markup-compatibility/2006">
-              <mc:Choice xmlns:v="urn:schemas-microsoft-com:vml" Requires="v">
-                <p:oleObj name="Equation" r:id="rId5" imgW="1651000" imgH="431800" progId="Equation.DSMT4">
-                  <p:embed/>
-                </p:oleObj>
-              </mc:Choice>
-              <mc:Fallback>
-                <p:oleObj name="Equation" r:id="rId5" imgW="1651000" imgH="431800" progId="Equation.DSMT4">
-                  <p:embed/>
-                  <p:pic>
-                    <p:nvPicPr>
-                      <p:cNvPr id="0" name=""/>
-                      <p:cNvPicPr>
-                        <a:picLocks noChangeAspect="1" noChangeArrowheads="1"/>
-                      </p:cNvPicPr>
-                      <p:nvPr/>
-                    </p:nvPicPr>
-                    <p:blipFill>
-                      <a:blip r:embed="rId6">
-                        <a:extLst>
-                          <a:ext uri="{28A0092B-C50C-407E-A947-70E740481C1C}">
-                            <a14:useLocalDpi xmlns:a14="http://schemas.microsoft.com/office/drawing/2010/main" val="0"/>
-                          </a:ext>
-                        </a:extLst>
-                      </a:blip>
-                      <a:srcRect/>
-                      <a:stretch>
-                        <a:fillRect/>
-                      </a:stretch>
-                    </p:blipFill>
-                    <p:spPr bwMode="auto">
-                      <a:xfrm>
-                        <a:off x="4297990" y="4872555"/>
-                        <a:ext cx="3616658" cy="947220"/>
-                      </a:xfrm>
-                      <a:prstGeom prst="rect">
-                        <a:avLst/>
-                      </a:prstGeom>
-                      <a:noFill/>
-                      <a:ln>
-                        <a:noFill/>
-                      </a:ln>
-                      <a:effectLst/>
-                    </p:spPr>
-                  </p:pic>
-                </p:oleObj>
-              </mc:Fallback>
-            </mc:AlternateContent>
-          </a:graphicData>
-        </a:graphic>
-      </p:graphicFrame>
       <p:sp>
         <p:nvSpPr>
           <p:cNvPr id="191493" name="TextBox 191492"/>
@@ -14439,6 +14215,100 @@
                 <a:latin typeface="Cambria"/>
               </a:rPr>
               <a:t> / k!</a:t>
+            </a:r>
+          </a:p>
+        </p:txBody>
+      </p:sp>
+      <p:sp>
+        <p:nvSpPr>
+          <p:cNvPr id="191495" name="TextBox 191494"/>
+          <p:cNvSpPr txBox="1"/>
+          <p:nvPr/>
+        </p:nvSpPr>
+        <p:spPr>
+          <a:xfrm>
+            <a:off x="4397471" y="2509997"/>
+            <a:ext cx="3094892" cy="728412"/>
+          </a:xfrm>
+          <a:prstGeom prst="rect">
+            <a:avLst/>
+          </a:prstGeom>
+          <a:noFill/>
+        </p:spPr>
+        <p:txBody>
+          <a:bodyPr wrap="square" anchor="ctr" lIns="0" rIns="0" tIns="0" bIns="0">
+            <a:spAutoFit/>
+          </a:bodyPr>
+          <a:lstStyle/>
+          <a:p>
+            <a:r>
+              <a:rPr sz="1900">
+                <a:latin typeface="Cambria"/>
+              </a:rPr>
+              <a:t>P(X = x) = μ</a:t>
+            </a:r>
+            <a:r>
+              <a:rPr sz="1900" baseline="30000">
+                <a:latin typeface="Cambria"/>
+              </a:rPr>
+              <a:t>x</a:t>
+            </a:r>
+            <a:r>
+              <a:rPr sz="1900">
+                <a:latin typeface="Cambria"/>
+              </a:rPr>
+              <a:t> e</a:t>
+            </a:r>
+            <a:r>
+              <a:rPr sz="1900" baseline="30000">
+                <a:latin typeface="Cambria"/>
+              </a:rPr>
+              <a:t>−μ</a:t>
+            </a:r>
+            <a:r>
+              <a:rPr sz="1900">
+                <a:latin typeface="Cambria"/>
+              </a:rPr>
+              <a:t> / x!</a:t>
+            </a:r>
+          </a:p>
+        </p:txBody>
+      </p:sp>
+      <p:sp>
+        <p:nvSpPr>
+          <p:cNvPr id="191496" name="TextBox 191495"/>
+          <p:cNvSpPr txBox="1"/>
+          <p:nvPr/>
+        </p:nvSpPr>
+        <p:spPr>
+          <a:xfrm>
+            <a:off x="4297990" y="4872555"/>
+            <a:ext cx="3616658" cy="947220"/>
+          </a:xfrm>
+          <a:prstGeom prst="rect">
+            <a:avLst/>
+          </a:prstGeom>
+          <a:noFill/>
+        </p:spPr>
+        <p:txBody>
+          <a:bodyPr wrap="square" anchor="ctr" lIns="0" rIns="0" tIns="0" bIns="0">
+            <a:spAutoFit/>
+          </a:bodyPr>
+          <a:lstStyle/>
+          <a:p>
+            <a:r>
+              <a:rPr sz="1800">
+                <a:latin typeface="Cambria"/>
+              </a:rPr>
+              <a:t>Mean : μ (rate per interval)</a:t>
+            </a:r>
+          </a:p>
+          <a:p>
+            <a:r>
+              <a:rPr sz="1800">
+                <a:latin typeface="Cambria"/>
+              </a:rPr>
+              <a:t>Variance : μ</a:t>
             </a:r>
           </a:p>
         </p:txBody>
@@ -15123,10 +14993,8 @@
                 <a:t> </a:t>
               </a:r>
               <a:r>
-                <a:rPr lang="en-US" altLang="en-US" sz="2000" dirty="0">
-                  <a:sym typeface="Wingdings" charset="2"/>
-                </a:rPr>
-                <a:t> 0</a:t>
+                <a:rPr lang="en-US" altLang="en-US" sz="2000" dirty="0"/>
+                <a:t>→ 0</a:t>
               </a:r>
               <a:endParaRPr lang="en-US" altLang="en-US" sz="2000" dirty="0"/>
             </a:p>
@@ -17245,150 +17113,6 @@
           </a:p>
         </p:txBody>
       </p:sp>
-      <p:graphicFrame>
-        <p:nvGraphicFramePr>
-          <p:cNvPr id="189443" name="Object 4"/>
-          <p:cNvGraphicFramePr>
-            <a:graphicFrameLocks noGrp="1" noChangeAspect="1"/>
-          </p:cNvGraphicFramePr>
-          <p:nvPr>
-            <p:ph sz="quarter" idx="2"/>
-            <p:extLst>
-              <p:ext uri="{D42A27DB-BD31-4B8C-83A1-F6EECF244321}">
-                <p14:modId xmlns:p14="http://schemas.microsoft.com/office/powerpoint/2010/main" val="368061340"/>
-              </p:ext>
-            </p:extLst>
-          </p:nvPr>
-        </p:nvGraphicFramePr>
-        <p:xfrm>
-          <a:off x="4397471" y="2509997"/>
-          <a:ext cx="2054225" cy="728412"/>
-        </p:xfrm>
-        <a:graphic>
-          <a:graphicData uri="http://schemas.openxmlformats.org/presentationml/2006/ole">
-            <mc:AlternateContent xmlns:mc="http://schemas.openxmlformats.org/markup-compatibility/2006">
-              <mc:Choice xmlns:v="urn:schemas-microsoft-com:vml" Requires="v">
-                <p:oleObj name="Equation" r:id="rId3" imgW="1180588" imgH="418918" progId="Equation.DSMT4">
-                  <p:embed/>
-                </p:oleObj>
-              </mc:Choice>
-              <mc:Fallback>
-                <p:oleObj name="Equation" r:id="rId3" imgW="1180588" imgH="418918" progId="Equation.DSMT4">
-                  <p:embed/>
-                  <p:pic>
-                    <p:nvPicPr>
-                      <p:cNvPr id="0" name=""/>
-                      <p:cNvPicPr>
-                        <a:picLocks noChangeAspect="1" noChangeArrowheads="1"/>
-                      </p:cNvPicPr>
-                      <p:nvPr/>
-                    </p:nvPicPr>
-                    <p:blipFill>
-                      <a:blip r:embed="rId4">
-                        <a:extLst>
-                          <a:ext uri="{28A0092B-C50C-407E-A947-70E740481C1C}">
-                            <a14:useLocalDpi xmlns:a14="http://schemas.microsoft.com/office/drawing/2010/main" val="0"/>
-                          </a:ext>
-                        </a:extLst>
-                      </a:blip>
-                      <a:srcRect/>
-                      <a:stretch>
-                        <a:fillRect/>
-                      </a:stretch>
-                    </p:blipFill>
-                    <p:spPr bwMode="auto">
-                      <a:xfrm>
-                        <a:off x="4397471" y="2509997"/>
-                        <a:ext cx="2054225" cy="728412"/>
-                      </a:xfrm>
-                      <a:prstGeom prst="rect">
-                        <a:avLst/>
-                      </a:prstGeom>
-                      <a:noFill/>
-                      <a:ln>
-                        <a:noFill/>
-                      </a:ln>
-                      <a:effectLst/>
-                    </p:spPr>
-                  </p:pic>
-                </p:oleObj>
-              </mc:Fallback>
-            </mc:AlternateContent>
-          </a:graphicData>
-        </a:graphic>
-      </p:graphicFrame>
-      <p:graphicFrame>
-        <p:nvGraphicFramePr>
-          <p:cNvPr id="191492" name="Object 6"/>
-          <p:cNvGraphicFramePr>
-            <a:graphicFrameLocks noGrp="1" noChangeAspect="1"/>
-          </p:cNvGraphicFramePr>
-          <p:nvPr>
-            <p:ph sz="quarter" idx="3"/>
-            <p:extLst>
-              <p:ext uri="{D42A27DB-BD31-4B8C-83A1-F6EECF244321}">
-                <p14:modId xmlns:p14="http://schemas.microsoft.com/office/powerpoint/2010/main" val="276206557"/>
-              </p:ext>
-            </p:extLst>
-          </p:nvPr>
-        </p:nvGraphicFramePr>
-        <p:xfrm>
-          <a:off x="4297990" y="4872555"/>
-          <a:ext cx="3616658" cy="947220"/>
-        </p:xfrm>
-        <a:graphic>
-          <a:graphicData uri="http://schemas.openxmlformats.org/presentationml/2006/ole">
-            <mc:AlternateContent xmlns:mc="http://schemas.openxmlformats.org/markup-compatibility/2006">
-              <mc:Choice xmlns:v="urn:schemas-microsoft-com:vml" Requires="v">
-                <p:oleObj name="Equation" r:id="rId5" imgW="1651000" imgH="431800" progId="Equation.DSMT4">
-                  <p:embed/>
-                </p:oleObj>
-              </mc:Choice>
-              <mc:Fallback>
-                <p:oleObj name="Equation" r:id="rId5" imgW="1651000" imgH="431800" progId="Equation.DSMT4">
-                  <p:embed/>
-                  <p:pic>
-                    <p:nvPicPr>
-                      <p:cNvPr id="0" name=""/>
-                      <p:cNvPicPr>
-                        <a:picLocks noChangeAspect="1" noChangeArrowheads="1"/>
-                      </p:cNvPicPr>
-                      <p:nvPr/>
-                    </p:nvPicPr>
-                    <p:blipFill>
-                      <a:blip r:embed="rId6">
-                        <a:extLst>
-                          <a:ext uri="{28A0092B-C50C-407E-A947-70E740481C1C}">
-                            <a14:useLocalDpi xmlns:a14="http://schemas.microsoft.com/office/drawing/2010/main" val="0"/>
-                          </a:ext>
-                        </a:extLst>
-                      </a:blip>
-                      <a:srcRect/>
-                      <a:stretch>
-                        <a:fillRect/>
-                      </a:stretch>
-                    </p:blipFill>
-                    <p:spPr bwMode="auto">
-                      <a:xfrm>
-                        <a:off x="4297990" y="4872555"/>
-                        <a:ext cx="3616658" cy="947220"/>
-                      </a:xfrm>
-                      <a:prstGeom prst="rect">
-                        <a:avLst/>
-                      </a:prstGeom>
-                      <a:noFill/>
-                      <a:ln>
-                        <a:noFill/>
-                      </a:ln>
-                      <a:effectLst/>
-                    </p:spPr>
-                  </p:pic>
-                </p:oleObj>
-              </mc:Fallback>
-            </mc:AlternateContent>
-          </a:graphicData>
-        </a:graphic>
-      </p:graphicFrame>
       <p:sp>
         <p:nvSpPr>
           <p:cNvPr id="191493" name="TextBox 191492"/>
@@ -17501,6 +17225,100 @@
                 <a:latin typeface="Cambria"/>
               </a:rPr>
               <a:t> / k!</a:t>
+            </a:r>
+          </a:p>
+        </p:txBody>
+      </p:sp>
+      <p:sp>
+        <p:nvSpPr>
+          <p:cNvPr id="191495" name="TextBox 191494"/>
+          <p:cNvSpPr txBox="1"/>
+          <p:nvPr/>
+        </p:nvSpPr>
+        <p:spPr>
+          <a:xfrm>
+            <a:off x="4397471" y="2509997"/>
+            <a:ext cx="3094892" cy="728412"/>
+          </a:xfrm>
+          <a:prstGeom prst="rect">
+            <a:avLst/>
+          </a:prstGeom>
+          <a:noFill/>
+        </p:spPr>
+        <p:txBody>
+          <a:bodyPr wrap="square" anchor="ctr" lIns="0" rIns="0" tIns="0" bIns="0">
+            <a:spAutoFit/>
+          </a:bodyPr>
+          <a:lstStyle/>
+          <a:p>
+            <a:r>
+              <a:rPr sz="1900">
+                <a:latin typeface="Cambria"/>
+              </a:rPr>
+              <a:t>P(X = x) = μ</a:t>
+            </a:r>
+            <a:r>
+              <a:rPr sz="1900" baseline="30000">
+                <a:latin typeface="Cambria"/>
+              </a:rPr>
+              <a:t>x</a:t>
+            </a:r>
+            <a:r>
+              <a:rPr sz="1900">
+                <a:latin typeface="Cambria"/>
+              </a:rPr>
+              <a:t> e</a:t>
+            </a:r>
+            <a:r>
+              <a:rPr sz="1900" baseline="30000">
+                <a:latin typeface="Cambria"/>
+              </a:rPr>
+              <a:t>−μ</a:t>
+            </a:r>
+            <a:r>
+              <a:rPr sz="1900">
+                <a:latin typeface="Cambria"/>
+              </a:rPr>
+              <a:t> / x!</a:t>
+            </a:r>
+          </a:p>
+        </p:txBody>
+      </p:sp>
+      <p:sp>
+        <p:nvSpPr>
+          <p:cNvPr id="191496" name="TextBox 191495"/>
+          <p:cNvSpPr txBox="1"/>
+          <p:nvPr/>
+        </p:nvSpPr>
+        <p:spPr>
+          <a:xfrm>
+            <a:off x="4297990" y="4872555"/>
+            <a:ext cx="3616658" cy="947220"/>
+          </a:xfrm>
+          <a:prstGeom prst="rect">
+            <a:avLst/>
+          </a:prstGeom>
+          <a:noFill/>
+        </p:spPr>
+        <p:txBody>
+          <a:bodyPr wrap="square" anchor="ctr" lIns="0" rIns="0" tIns="0" bIns="0">
+            <a:spAutoFit/>
+          </a:bodyPr>
+          <a:lstStyle/>
+          <a:p>
+            <a:r>
+              <a:rPr sz="1800">
+                <a:latin typeface="Cambria"/>
+              </a:rPr>
+              <a:t>Mean : μ (rate per interval)</a:t>
+            </a:r>
+          </a:p>
+          <a:p>
+            <a:r>
+              <a:rPr sz="1800">
+                <a:latin typeface="Cambria"/>
+              </a:rPr>
+              <a:t>Variance : μ</a:t>
             </a:r>
           </a:p>
         </p:txBody>
@@ -17973,10 +17791,8 @@
               <a:defRPr/>
             </a:pPr>
             <a:r>
-              <a:rPr lang="en-US" altLang="en-US" sz="2400" i="0">
-                <a:sym typeface="Symbol" charset="2"/>
-              </a:rPr>
-              <a:t>=2</a:t>
+              <a:rPr lang="en-US" altLang="en-US" sz="2400" i="0"/>
+              <a:t>μ=2</a:t>
             </a:r>
           </a:p>
         </p:txBody>
@@ -18140,10 +17956,8 @@
               <a:defRPr/>
             </a:pPr>
             <a:r>
-              <a:rPr lang="en-US" altLang="en-US" sz="2400" i="0">
-                <a:sym typeface="Symbol" charset="2"/>
-              </a:rPr>
-              <a:t>=5</a:t>
+              <a:rPr lang="en-US" altLang="en-US" sz="2400" i="0"/>
+              <a:t>μ=5</a:t>
             </a:r>
           </a:p>
         </p:txBody>
@@ -18307,10 +18121,8 @@
               <a:defRPr/>
             </a:pPr>
             <a:r>
-              <a:rPr lang="en-US" altLang="en-US" sz="2400" i="0">
-                <a:sym typeface="Symbol" charset="2"/>
-              </a:rPr>
-              <a:t>=8</a:t>
+              <a:rPr lang="en-US" altLang="en-US" sz="2400" i="0"/>
+              <a:t>μ=8</a:t>
             </a:r>
           </a:p>
         </p:txBody>
@@ -18450,77 +18262,6 @@
           </a:p>
         </p:txBody>
       </p:sp>
-      <p:graphicFrame>
-        <p:nvGraphicFramePr>
-          <p:cNvPr id="4" name="Object 4"/>
-          <p:cNvGraphicFramePr>
-            <a:graphicFrameLocks noChangeAspect="1"/>
-          </p:cNvGraphicFramePr>
-          <p:nvPr>
-            <p:extLst>
-              <p:ext uri="{D42A27DB-BD31-4B8C-83A1-F6EECF244321}">
-                <p14:modId xmlns:p14="http://schemas.microsoft.com/office/powerpoint/2010/main" val="1764011272"/>
-              </p:ext>
-            </p:extLst>
-          </p:nvPr>
-        </p:nvGraphicFramePr>
-        <p:xfrm>
-          <a:off x="4818820" y="4919723"/>
-          <a:ext cx="2554360" cy="905756"/>
-        </p:xfrm>
-        <a:graphic>
-          <a:graphicData uri="http://schemas.openxmlformats.org/presentationml/2006/ole">
-            <mc:AlternateContent xmlns:mc="http://schemas.openxmlformats.org/markup-compatibility/2006">
-              <mc:Choice xmlns:v="urn:schemas-microsoft-com:vml" Requires="v">
-                <p:oleObj name="Equation" r:id="rId3" imgW="1180588" imgH="418918" progId="Equation.DSMT4">
-                  <p:embed/>
-                </p:oleObj>
-              </mc:Choice>
-              <mc:Fallback>
-                <p:oleObj name="Equation" r:id="rId3" imgW="1180588" imgH="418918" progId="Equation.DSMT4">
-                  <p:embed/>
-                  <p:pic>
-                    <p:nvPicPr>
-                      <p:cNvPr id="0" name=""/>
-                      <p:cNvPicPr>
-                        <a:picLocks noChangeAspect="1" noChangeArrowheads="1"/>
-                      </p:cNvPicPr>
-                      <p:nvPr/>
-                    </p:nvPicPr>
-                    <p:blipFill>
-                      <a:blip r:embed="rId4">
-                        <a:extLst>
-                          <a:ext uri="{28A0092B-C50C-407E-A947-70E740481C1C}">
-                            <a14:useLocalDpi xmlns:a14="http://schemas.microsoft.com/office/drawing/2010/main" val="0"/>
-                          </a:ext>
-                        </a:extLst>
-                      </a:blip>
-                      <a:srcRect/>
-                      <a:stretch>
-                        <a:fillRect/>
-                      </a:stretch>
-                    </p:blipFill>
-                    <p:spPr bwMode="auto">
-                      <a:xfrm>
-                        <a:off x="4818820" y="4919723"/>
-                        <a:ext cx="2554360" cy="905756"/>
-                      </a:xfrm>
-                      <a:prstGeom prst="rect">
-                        <a:avLst/>
-                      </a:prstGeom>
-                      <a:noFill/>
-                      <a:ln>
-                        <a:noFill/>
-                      </a:ln>
-                      <a:effectLst/>
-                    </p:spPr>
-                  </p:pic>
-                </p:oleObj>
-              </mc:Fallback>
-            </mc:AlternateContent>
-          </a:graphicData>
-        </a:graphic>
-      </p:graphicFrame>
       <p:sp>
         <p:nvSpPr>
           <p:cNvPr id="2" name="TextBox 1"/>
@@ -18585,6 +18326,61 @@
                 </a:solidFill>
               </a:rPr>
               <a:t>Group Work</a:t>
+            </a:r>
+          </a:p>
+        </p:txBody>
+      </p:sp>
+      <p:sp>
+        <p:nvSpPr>
+          <p:cNvPr id="6148" name="TextBox 6147"/>
+          <p:cNvSpPr txBox="1"/>
+          <p:nvPr/>
+        </p:nvSpPr>
+        <p:spPr>
+          <a:xfrm>
+            <a:off x="4818820" y="4919723"/>
+            <a:ext cx="3094892" cy="905756"/>
+          </a:xfrm>
+          <a:prstGeom prst="rect">
+            <a:avLst/>
+          </a:prstGeom>
+          <a:noFill/>
+        </p:spPr>
+        <p:txBody>
+          <a:bodyPr wrap="square" anchor="ctr" lIns="0" rIns="0" tIns="0" bIns="0">
+            <a:spAutoFit/>
+          </a:bodyPr>
+          <a:lstStyle/>
+          <a:p>
+            <a:r>
+              <a:rPr sz="1900">
+                <a:latin typeface="Cambria"/>
+              </a:rPr>
+              <a:t>P(X = x) = μ</a:t>
+            </a:r>
+            <a:r>
+              <a:rPr sz="1900" baseline="30000">
+                <a:latin typeface="Cambria"/>
+              </a:rPr>
+              <a:t>x</a:t>
+            </a:r>
+            <a:r>
+              <a:rPr sz="1900">
+                <a:latin typeface="Cambria"/>
+              </a:rPr>
+              <a:t> e</a:t>
+            </a:r>
+            <a:r>
+              <a:rPr sz="1900" baseline="30000">
+                <a:latin typeface="Cambria"/>
+              </a:rPr>
+              <a:t>−μ</a:t>
+            </a:r>
+            <a:r>
+              <a:rPr sz="1900">
+                <a:latin typeface="Cambria"/>
+              </a:rPr>
+              <a:t> / x!</a:t>
             </a:r>
           </a:p>
         </p:txBody>
@@ -18775,106 +18571,6 @@
           </a:p>
         </p:txBody>
       </p:sp>
-      <p:graphicFrame>
-        <p:nvGraphicFramePr>
-          <p:cNvPr id="7172" name="Object 6"/>
-          <p:cNvGraphicFramePr>
-            <a:graphicFrameLocks noGrp="1" noChangeAspect="1"/>
-          </p:cNvGraphicFramePr>
-          <p:nvPr>
-            <p:ph sz="half" idx="2"/>
-            <p:extLst>
-              <p:ext uri="{D42A27DB-BD31-4B8C-83A1-F6EECF244321}">
-                <p14:modId xmlns:p14="http://schemas.microsoft.com/office/powerpoint/2010/main" val="1390098713"/>
-              </p:ext>
-            </p:extLst>
-          </p:nvPr>
-        </p:nvGraphicFramePr>
-        <p:xfrm>
-          <a:off x="3200400" y="3895533"/>
-          <a:ext cx="5410200" cy="1055688"/>
-        </p:xfrm>
-        <a:graphic>
-          <a:graphicData uri="http://schemas.openxmlformats.org/presentationml/2006/ole">
-            <mc:AlternateContent xmlns:mc="http://schemas.openxmlformats.org/markup-compatibility/2006">
-              <mc:Choice xmlns:v="urn:schemas-microsoft-com:vml" Requires="v">
-                <p:oleObj name="Equation" r:id="rId3" imgW="2146300" imgH="419100" progId="Equation.DSMT4">
-                  <p:embed/>
-                </p:oleObj>
-              </mc:Choice>
-              <mc:Fallback>
-                <p:oleObj name="Equation" r:id="rId3" imgW="2146300" imgH="419100" progId="Equation.DSMT4">
-                  <p:embed/>
-                  <p:pic>
-                    <p:nvPicPr>
-                      <p:cNvPr id="0" name=""/>
-                      <p:cNvPicPr>
-                        <a:picLocks noChangeAspect="1" noChangeArrowheads="1"/>
-                      </p:cNvPicPr>
-                      <p:nvPr/>
-                    </p:nvPicPr>
-                    <p:blipFill>
-                      <a:blip r:embed="rId4">
-                        <a:extLst>
-                          <a:ext uri="{28A0092B-C50C-407E-A947-70E740481C1C}">
-                            <a14:useLocalDpi xmlns:a14="http://schemas.microsoft.com/office/drawing/2010/main" val="0"/>
-                          </a:ext>
-                        </a:extLst>
-                      </a:blip>
-                      <a:srcRect/>
-                      <a:stretch>
-                        <a:fillRect/>
-                      </a:stretch>
-                    </p:blipFill>
-                    <p:spPr bwMode="auto">
-                      <a:xfrm>
-                        <a:off x="3200400" y="3895533"/>
-                        <a:ext cx="5410200" cy="1055688"/>
-                      </a:xfrm>
-                      <a:prstGeom prst="rect">
-                        <a:avLst/>
-                      </a:prstGeom>
-                      <a:noFill/>
-                      <a:ln>
-                        <a:noFill/>
-                      </a:ln>
-                      <a:effectLst/>
-                      <a:extLst>
-                        <a:ext uri="{909E8E84-426E-40DD-AFC4-6F175D3DCCD1}">
-                          <a14:hiddenFill xmlns:a14="http://schemas.microsoft.com/office/drawing/2010/main">
-                            <a:solidFill>
-                              <a:srgbClr val="FFFFFF"/>
-                            </a:solidFill>
-                          </a14:hiddenFill>
-                        </a:ext>
-                        <a:ext uri="{91240B29-F687-4F45-9708-019B960494DF}">
-                          <a14:hiddenLine xmlns:a14="http://schemas.microsoft.com/office/drawing/2010/main" w="9525">
-                            <a:solidFill>
-                              <a:srgbClr val="000000"/>
-                            </a:solidFill>
-                            <a:miter lim="800000"/>
-                            <a:headEnd/>
-                            <a:tailEnd/>
-                          </a14:hiddenLine>
-                        </a:ext>
-                        <a:ext uri="{AF507438-7753-43E0-B8FC-AC1667EBCBE1}">
-                          <a14:hiddenEffects xmlns:a14="http://schemas.microsoft.com/office/drawing/2010/main">
-                            <a:effectLst>
-                              <a:outerShdw dist="35921" dir="2700000" algn="ctr" rotWithShape="0">
-                                <a:srgbClr val="808080"/>
-                              </a:outerShdw>
-                            </a:effectLst>
-                          </a14:hiddenEffects>
-                        </a:ext>
-                      </a:extLst>
-                    </p:spPr>
-                  </p:pic>
-                </p:oleObj>
-              </mc:Fallback>
-            </mc:AlternateContent>
-          </a:graphicData>
-        </a:graphic>
-      </p:graphicFrame>
       <p:pic>
         <p:nvPicPr>
           <p:cNvPr id="2" name="Picture 1" descr="R console: dpois(4,3) returns 0.1680314, the Poisson probability of exactly 4 events when the mean is 3." title="R console: dpois(4,3) returns 0.1680314, the Poisson probability of exactly 4 ev"/>
@@ -18929,6 +18625,85 @@
           </a:extLst>
         </p:spPr>
       </p:pic>
+      <p:sp>
+        <p:nvSpPr>
+          <p:cNvPr id="7172" name="TextBox 7171"/>
+          <p:cNvSpPr txBox="1"/>
+          <p:nvPr/>
+        </p:nvSpPr>
+        <p:spPr>
+          <a:xfrm>
+            <a:off x="3200400" y="3895533"/>
+            <a:ext cx="6189784" cy="1055688"/>
+          </a:xfrm>
+          <a:prstGeom prst="rect">
+            <a:avLst/>
+          </a:prstGeom>
+          <a:noFill/>
+        </p:spPr>
+        <p:txBody>
+          <a:bodyPr wrap="square" anchor="ctr" lIns="0" rIns="0" tIns="0" bIns="0">
+            <a:spAutoFit/>
+          </a:bodyPr>
+          <a:lstStyle/>
+          <a:p>
+            <a:r>
+              <a:rPr sz="1900">
+                <a:latin typeface="Cambria"/>
+              </a:rPr>
+              <a:t>P[X = 4] = μ</a:t>
+            </a:r>
+            <a:r>
+              <a:rPr sz="1900" baseline="30000">
+                <a:latin typeface="Cambria"/>
+              </a:rPr>
+              <a:t>x</a:t>
+            </a:r>
+            <a:r>
+              <a:rPr sz="1900">
+                <a:latin typeface="Cambria"/>
+              </a:rPr>
+              <a:t> e</a:t>
+            </a:r>
+            <a:r>
+              <a:rPr sz="1900" baseline="30000">
+                <a:latin typeface="Cambria"/>
+              </a:rPr>
+              <a:t>−μ</a:t>
+            </a:r>
+            <a:r>
+              <a:rPr sz="1900">
+                <a:latin typeface="Cambria"/>
+              </a:rPr>
+              <a:t> / x! = 3</a:t>
+            </a:r>
+            <a:r>
+              <a:rPr sz="1900" baseline="30000">
+                <a:latin typeface="Cambria"/>
+              </a:rPr>
+              <a:t>4</a:t>
+            </a:r>
+            <a:r>
+              <a:rPr sz="1900">
+                <a:latin typeface="Cambria"/>
+              </a:rPr>
+              <a:t> e</a:t>
+            </a:r>
+            <a:r>
+              <a:rPr sz="1900" baseline="30000">
+                <a:latin typeface="Cambria"/>
+              </a:rPr>
+              <a:t>−3</a:t>
+            </a:r>
+            <a:r>
+              <a:rPr sz="1900">
+                <a:latin typeface="Cambria"/>
+              </a:rPr>
+              <a:t> / 4! = 0.168</a:t>
+            </a:r>
+          </a:p>
+        </p:txBody>
+      </p:sp>
     </p:spTree>
     <p:extLst>
       <p:ext uri="{BB962C8B-B14F-4D97-AF65-F5344CB8AC3E}">
@@ -19178,99 +18953,12 @@
               <a:t>P[X</a:t>
             </a:r>
             <a:r>
-              <a:rPr lang="en-US" altLang="en-US" dirty="0">
-                <a:sym typeface="Symbol" charset="2"/>
-              </a:rPr>
-              <a:t>2]=P[X=0]+P[X=1]+P[X=2]=</a:t>
+              <a:rPr lang="en-US" altLang="en-US" dirty="0"/>
+              <a:t>≤2]=P[X=0]+P[X=1]+P[X=2]=</a:t>
             </a:r>
           </a:p>
         </p:txBody>
       </p:sp>
-      <p:graphicFrame>
-        <p:nvGraphicFramePr>
-          <p:cNvPr id="8196" name="Object 4"/>
-          <p:cNvGraphicFramePr>
-            <a:graphicFrameLocks noGrp="1" noChangeAspect="1"/>
-          </p:cNvGraphicFramePr>
-          <p:nvPr>
-            <p:ph sz="half" idx="2"/>
-          </p:nvPr>
-        </p:nvGraphicFramePr>
-        <p:xfrm>
-          <a:off x="1524000" y="5334001"/>
-          <a:ext cx="4267200" cy="804863"/>
-        </p:xfrm>
-        <a:graphic>
-          <a:graphicData uri="http://schemas.openxmlformats.org/presentationml/2006/ole">
-            <mc:AlternateContent xmlns:mc="http://schemas.openxmlformats.org/markup-compatibility/2006">
-              <mc:Choice xmlns:v="urn:schemas-microsoft-com:vml" Requires="v">
-                <p:oleObj name="Equation" r:id="rId3" imgW="2222500" imgH="419100" progId="Equation.DSMT4">
-                  <p:embed/>
-                </p:oleObj>
-              </mc:Choice>
-              <mc:Fallback>
-                <p:oleObj name="Equation" r:id="rId3" imgW="2222500" imgH="419100" progId="Equation.DSMT4">
-                  <p:embed/>
-                  <p:pic>
-                    <p:nvPicPr>
-                      <p:cNvPr id="0" name=""/>
-                      <p:cNvPicPr>
-                        <a:picLocks noChangeAspect="1" noChangeArrowheads="1"/>
-                      </p:cNvPicPr>
-                      <p:nvPr/>
-                    </p:nvPicPr>
-                    <p:blipFill>
-                      <a:blip r:embed="rId4">
-                        <a:extLst>
-                          <a:ext uri="{28A0092B-C50C-407E-A947-70E740481C1C}">
-                            <a14:useLocalDpi xmlns:a14="http://schemas.microsoft.com/office/drawing/2010/main" val="0"/>
-                          </a:ext>
-                        </a:extLst>
-                      </a:blip>
-                      <a:srcRect/>
-                      <a:stretch>
-                        <a:fillRect/>
-                      </a:stretch>
-                    </p:blipFill>
-                    <p:spPr bwMode="auto">
-                      <a:xfrm>
-                        <a:off x="1524000" y="5334001"/>
-                        <a:ext cx="4267200" cy="804863"/>
-                      </a:xfrm>
-                      <a:prstGeom prst="rect">
-                        <a:avLst/>
-                      </a:prstGeom>
-                      <a:noFill/>
-                      <a:ln>
-                        <a:noFill/>
-                      </a:ln>
-                      <a:extLst>
-                        <a:ext uri="{909E8E84-426E-40DD-AFC4-6F175D3DCCD1}">
-                          <a14:hiddenFill xmlns:a14="http://schemas.microsoft.com/office/drawing/2010/main">
-                            <a:solidFill>
-                              <a:schemeClr val="accent1"/>
-                            </a:solidFill>
-                          </a14:hiddenFill>
-                        </a:ext>
-                        <a:ext uri="{91240B29-F687-4F45-9708-019B960494DF}">
-                          <a14:hiddenLine xmlns:a14="http://schemas.microsoft.com/office/drawing/2010/main" w="9525">
-                            <a:solidFill>
-                              <a:schemeClr val="tx1"/>
-                            </a:solidFill>
-                            <a:miter lim="800000"/>
-                            <a:headEnd/>
-                            <a:tailEnd/>
-                          </a14:hiddenLine>
-                        </a:ext>
-                      </a:extLst>
-                    </p:spPr>
-                  </p:pic>
-                </p:oleObj>
-              </mc:Fallback>
-            </mc:AlternateContent>
-          </a:graphicData>
-        </a:graphic>
-      </p:graphicFrame>
       <p:pic>
         <p:nvPicPr>
           <p:cNvPr id="2" name="Picture 1" descr="R console: dpois(0,3)+dpois(1,3)+dpois(2,3)=0.4231901 and ppois(2,3)=0.4231901, the Poisson probability of 2 or fewer events when the mean is 3." title="R console: dpois(0,3)+dpois(1,3)+dpois(2,3)=0.4231901 and ppois(2,3)=0.4231901, "/>
@@ -19325,6 +19013,85 @@
           </a:extLst>
         </p:spPr>
       </p:pic>
+      <p:sp>
+        <p:nvSpPr>
+          <p:cNvPr id="8196" name="TextBox 8195"/>
+          <p:cNvSpPr txBox="1"/>
+          <p:nvPr/>
+        </p:nvSpPr>
+        <p:spPr>
+          <a:xfrm>
+            <a:off x="1524000" y="5334001"/>
+            <a:ext cx="6752492" cy="804863"/>
+          </a:xfrm>
+          <a:prstGeom prst="rect">
+            <a:avLst/>
+          </a:prstGeom>
+          <a:noFill/>
+        </p:spPr>
+        <p:txBody>
+          <a:bodyPr wrap="square" anchor="ctr" lIns="0" rIns="0" tIns="0" bIns="0">
+            <a:spAutoFit/>
+          </a:bodyPr>
+          <a:lstStyle/>
+          <a:p>
+            <a:r>
+              <a:rPr sz="1900">
+                <a:latin typeface="Cambria"/>
+              </a:rPr>
+              <a:t>P[X ≤ 2] = e</a:t>
+            </a:r>
+            <a:r>
+              <a:rPr sz="1900" baseline="30000">
+                <a:latin typeface="Cambria"/>
+              </a:rPr>
+              <a:t>−3</a:t>
+            </a:r>
+            <a:r>
+              <a:rPr sz="1900">
+                <a:latin typeface="Cambria"/>
+              </a:rPr>
+              <a:t> [ 3</a:t>
+            </a:r>
+            <a:r>
+              <a:rPr sz="1900" baseline="30000">
+                <a:latin typeface="Cambria"/>
+              </a:rPr>
+              <a:t>0</a:t>
+            </a:r>
+            <a:r>
+              <a:rPr sz="1900">
+                <a:latin typeface="Cambria"/>
+              </a:rPr>
+              <a:t>/0! + 3</a:t>
+            </a:r>
+            <a:r>
+              <a:rPr sz="1900" baseline="30000">
+                <a:latin typeface="Cambria"/>
+              </a:rPr>
+              <a:t>1</a:t>
+            </a:r>
+            <a:r>
+              <a:rPr sz="1900">
+                <a:latin typeface="Cambria"/>
+              </a:rPr>
+              <a:t>/1! + 3</a:t>
+            </a:r>
+            <a:r>
+              <a:rPr sz="1900" baseline="30000">
+                <a:latin typeface="Cambria"/>
+              </a:rPr>
+              <a:t>2</a:t>
+            </a:r>
+            <a:r>
+              <a:rPr sz="1900">
+                <a:latin typeface="Cambria"/>
+              </a:rPr>
+              <a:t>/2! ] = 0.423</a:t>
+            </a:r>
+          </a:p>
+        </p:txBody>
+      </p:sp>
     </p:spTree>
     <p:extLst>
       <p:ext uri="{BB962C8B-B14F-4D97-AF65-F5344CB8AC3E}">
@@ -20160,10 +19927,8 @@
               <a:t> </a:t>
             </a:r>
             <a:r>
-              <a:rPr lang="en-US" altLang="en-US" dirty="0">
-                <a:sym typeface="Wingdings"/>
-              </a:rPr>
-              <a:t> Onward to negative binomial!</a:t>
+              <a:rPr lang="en-US" altLang="en-US" dirty="0"/>
+              <a:t>→ Onward to negative binomial!</a:t>
             </a:r>
             <a:endParaRPr lang="en-US" altLang="en-US" dirty="0"/>
           </a:p>
@@ -21123,77 +20888,6 @@
           </a:p>
         </p:txBody>
       </p:sp>
-      <p:graphicFrame>
-        <p:nvGraphicFramePr>
-          <p:cNvPr id="143362" name="Object 4"/>
-          <p:cNvGraphicFramePr>
-            <a:graphicFrameLocks noGrp="1" noChangeAspect="1"/>
-          </p:cNvGraphicFramePr>
-          <p:nvPr>
-            <p:ph idx="1"/>
-            <p:extLst>
-              <p:ext uri="{D42A27DB-BD31-4B8C-83A1-F6EECF244321}">
-                <p14:modId xmlns:p14="http://schemas.microsoft.com/office/powerpoint/2010/main" val="2017998080"/>
-              </p:ext>
-            </p:extLst>
-          </p:nvPr>
-        </p:nvGraphicFramePr>
-        <p:xfrm>
-          <a:off x="2101534" y="2770188"/>
-          <a:ext cx="8801398" cy="2033032"/>
-        </p:xfrm>
-        <a:graphic>
-          <a:graphicData uri="http://schemas.openxmlformats.org/presentationml/2006/ole">
-            <mc:AlternateContent xmlns:mc="http://schemas.openxmlformats.org/markup-compatibility/2006">
-              <mc:Choice xmlns:v="urn:schemas-microsoft-com:vml" Requires="v">
-                <p:oleObj name="Equation" r:id="rId3" imgW="3847204" imgH="889046" progId="">
-                  <p:embed/>
-                </p:oleObj>
-              </mc:Choice>
-              <mc:Fallback>
-                <p:oleObj name="Equation" r:id="rId3" imgW="3847204" imgH="889046" progId="">
-                  <p:embed/>
-                  <p:pic>
-                    <p:nvPicPr>
-                      <p:cNvPr id="0" name=""/>
-                      <p:cNvPicPr>
-                        <a:picLocks noGrp="1" noChangeAspect="1" noChangeArrowheads="1"/>
-                      </p:cNvPicPr>
-                      <p:nvPr/>
-                    </p:nvPicPr>
-                    <p:blipFill>
-                      <a:blip r:embed="rId4">
-                        <a:extLst>
-                          <a:ext uri="{28A0092B-C50C-407E-A947-70E740481C1C}">
-                            <a14:useLocalDpi xmlns:a14="http://schemas.microsoft.com/office/drawing/2010/main" val="0"/>
-                          </a:ext>
-                        </a:extLst>
-                      </a:blip>
-                      <a:srcRect/>
-                      <a:stretch>
-                        <a:fillRect/>
-                      </a:stretch>
-                    </p:blipFill>
-                    <p:spPr bwMode="auto">
-                      <a:xfrm>
-                        <a:off x="2101534" y="2770188"/>
-                        <a:ext cx="8801398" cy="2033032"/>
-                      </a:xfrm>
-                      <a:prstGeom prst="rect">
-                        <a:avLst/>
-                      </a:prstGeom>
-                      <a:noFill/>
-                      <a:ln>
-                        <a:noFill/>
-                      </a:ln>
-                    </p:spPr>
-                  </p:pic>
-                </p:oleObj>
-              </mc:Fallback>
-            </mc:AlternateContent>
-          </a:graphicData>
-        </a:graphic>
-      </p:graphicFrame>
       <p:sp>
         <p:nvSpPr>
           <p:cNvPr id="143363" name="Rectangle 4"/>
@@ -21765,6 +21459,61 @@
               <a:t>Also N</a:t>
             </a:r>
             <a:endParaRPr lang="en-US" sz="2800" i="1" dirty="0"/>
+          </a:p>
+        </p:txBody>
+      </p:sp>
+      <p:sp>
+        <p:nvSpPr>
+          <p:cNvPr id="143365" name="TextBox 143364"/>
+          <p:cNvSpPr txBox="1"/>
+          <p:nvPr/>
+        </p:nvSpPr>
+        <p:spPr>
+          <a:xfrm>
+            <a:off x="2101534" y="2770188"/>
+            <a:ext cx="8801398" cy="2033032"/>
+          </a:xfrm>
+          <a:prstGeom prst="rect">
+            <a:avLst/>
+          </a:prstGeom>
+          <a:noFill/>
+        </p:spPr>
+        <p:txBody>
+          <a:bodyPr wrap="square" anchor="ctr" lIns="0" rIns="0" tIns="0" bIns="0">
+            <a:spAutoFit/>
+          </a:bodyPr>
+          <a:lstStyle/>
+          <a:p>
+            <a:r>
+              <a:rPr sz="1700">
+                <a:latin typeface="Cambria"/>
+              </a:rPr>
+              <a:t>n            The number of times a trial is repeated</a:t>
+            </a:r>
+          </a:p>
+          <a:p>
+            <a:r>
+              <a:rPr sz="1700">
+                <a:latin typeface="Cambria"/>
+              </a:rPr>
+              <a:t>p = P(S)     The probability of a success in a single trial</a:t>
+            </a:r>
+          </a:p>
+          <a:p>
+            <a:r>
+              <a:rPr sz="1700">
+                <a:latin typeface="Cambria"/>
+              </a:rPr>
+              <a:t>q = P(F)     The probability of a failure in a single trial, q = 1 − p</a:t>
+            </a:r>
+          </a:p>
+          <a:p>
+            <a:r>
+              <a:rPr sz="1700">
+                <a:latin typeface="Cambria"/>
+              </a:rPr>
+              <a:t>x            The number of successes on n trials (x = 0, 1, .., n)</a:t>
+            </a:r>
           </a:p>
         </p:txBody>
       </p:sp>
@@ -30373,77 +30122,6 @@
           </a:p>
         </p:txBody>
       </p:sp>
-      <p:graphicFrame>
-        <p:nvGraphicFramePr>
-          <p:cNvPr id="145411" name="Object 4"/>
-          <p:cNvGraphicFramePr>
-            <a:graphicFrameLocks noGrp="1" noChangeAspect="1"/>
-          </p:cNvGraphicFramePr>
-          <p:nvPr>
-            <p:ph sz="half" idx="2"/>
-            <p:extLst>
-              <p:ext uri="{D42A27DB-BD31-4B8C-83A1-F6EECF244321}">
-                <p14:modId xmlns:p14="http://schemas.microsoft.com/office/powerpoint/2010/main" val="575213071"/>
-              </p:ext>
-            </p:extLst>
-          </p:nvPr>
-        </p:nvGraphicFramePr>
-        <p:xfrm>
-          <a:off x="3733623" y="2011680"/>
-          <a:ext cx="4785714" cy="867410"/>
-        </p:xfrm>
-        <a:graphic>
-          <a:graphicData uri="http://schemas.openxmlformats.org/presentationml/2006/ole">
-            <mc:AlternateContent xmlns:mc="http://schemas.openxmlformats.org/markup-compatibility/2006">
-              <mc:Choice xmlns:v="urn:schemas-microsoft-com:vml" Requires="v">
-                <p:oleObj name="Equation" r:id="rId3" imgW="2311078" imgH="418893" progId="">
-                  <p:embed/>
-                </p:oleObj>
-              </mc:Choice>
-              <mc:Fallback>
-                <p:oleObj name="Equation" r:id="rId3" imgW="2311078" imgH="418893" progId="">
-                  <p:embed/>
-                  <p:pic>
-                    <p:nvPicPr>
-                      <p:cNvPr id="0" name=""/>
-                      <p:cNvPicPr>
-                        <a:picLocks noGrp="1" noChangeAspect="1" noChangeArrowheads="1"/>
-                      </p:cNvPicPr>
-                      <p:nvPr/>
-                    </p:nvPicPr>
-                    <p:blipFill>
-                      <a:blip r:embed="rId4">
-                        <a:extLst>
-                          <a:ext uri="{28A0092B-C50C-407E-A947-70E740481C1C}">
-                            <a14:useLocalDpi xmlns:a14="http://schemas.microsoft.com/office/drawing/2010/main" val="0"/>
-                          </a:ext>
-                        </a:extLst>
-                      </a:blip>
-                      <a:srcRect/>
-                      <a:stretch>
-                        <a:fillRect/>
-                      </a:stretch>
-                    </p:blipFill>
-                    <p:spPr bwMode="auto">
-                      <a:xfrm>
-                        <a:off x="3733623" y="2011680"/>
-                        <a:ext cx="4785714" cy="867410"/>
-                      </a:xfrm>
-                      <a:prstGeom prst="rect">
-                        <a:avLst/>
-                      </a:prstGeom>
-                      <a:noFill/>
-                      <a:ln>
-                        <a:noFill/>
-                      </a:ln>
-                    </p:spPr>
-                  </p:pic>
-                </p:oleObj>
-              </mc:Fallback>
-            </mc:AlternateContent>
-          </a:graphicData>
-        </a:graphic>
-      </p:graphicFrame>
       <p:cxnSp>
         <p:nvCxnSpPr>
           <p:cNvPr id="3" name="Straight Arrow Connector 2"/>
@@ -30531,6 +30209,103 @@
           </a:p>
         </p:txBody>
       </p:sp>
+      <p:sp>
+        <p:nvSpPr>
+          <p:cNvPr id="7172" name="TextBox 7171"/>
+          <p:cNvSpPr txBox="1"/>
+          <p:nvPr/>
+        </p:nvSpPr>
+        <p:spPr>
+          <a:xfrm>
+            <a:off x="3733623" y="2011680"/>
+            <a:ext cx="6893169" cy="867410"/>
+          </a:xfrm>
+          <a:prstGeom prst="rect">
+            <a:avLst/>
+          </a:prstGeom>
+          <a:noFill/>
+        </p:spPr>
+        <p:txBody>
+          <a:bodyPr wrap="square" anchor="ctr" lIns="0" rIns="0" tIns="0" bIns="0">
+            <a:spAutoFit/>
+          </a:bodyPr>
+          <a:lstStyle/>
+          <a:p>
+            <a:r>
+              <a:rPr sz="1900">
+                <a:latin typeface="Cambria"/>
+              </a:rPr>
+              <a:t>P(x) = </a:t>
+            </a:r>
+            <a:r>
+              <a:rPr sz="1900" baseline="-25000">
+                <a:latin typeface="Cambria"/>
+              </a:rPr>
+              <a:t>n</a:t>
+            </a:r>
+            <a:r>
+              <a:rPr sz="1900">
+                <a:latin typeface="Cambria"/>
+              </a:rPr>
+              <a:t>C</a:t>
+            </a:r>
+            <a:r>
+              <a:rPr sz="1900" baseline="-25000">
+                <a:latin typeface="Cambria"/>
+              </a:rPr>
+              <a:t>x</a:t>
+            </a:r>
+            <a:r>
+              <a:rPr sz="1900">
+                <a:latin typeface="Cambria"/>
+              </a:rPr>
+              <a:t> p</a:t>
+            </a:r>
+            <a:r>
+              <a:rPr sz="1900" baseline="30000">
+                <a:latin typeface="Cambria"/>
+              </a:rPr>
+              <a:t>x</a:t>
+            </a:r>
+            <a:r>
+              <a:rPr sz="1900">
+                <a:latin typeface="Cambria"/>
+              </a:rPr>
+              <a:t> q</a:t>
+            </a:r>
+            <a:r>
+              <a:rPr sz="1900" baseline="30000">
+                <a:latin typeface="Cambria"/>
+              </a:rPr>
+              <a:t>n−x</a:t>
+            </a:r>
+            <a:r>
+              <a:rPr sz="1900">
+                <a:latin typeface="Cambria"/>
+              </a:rPr>
+              <a:t> = n! / ((n − x)! x!) · p</a:t>
+            </a:r>
+            <a:r>
+              <a:rPr sz="1900" baseline="30000">
+                <a:latin typeface="Cambria"/>
+              </a:rPr>
+              <a:t>x</a:t>
+            </a:r>
+            <a:r>
+              <a:rPr sz="1900">
+                <a:latin typeface="Cambria"/>
+              </a:rPr>
+              <a:t> q</a:t>
+            </a:r>
+            <a:r>
+              <a:rPr sz="1900" baseline="30000">
+                <a:latin typeface="Cambria"/>
+              </a:rPr>
+              <a:t>n−x</a:t>
+            </a:r>
+          </a:p>
+        </p:txBody>
+      </p:sp>
     </p:spTree>
     <p:extLst>
       <p:ext uri="{BB962C8B-B14F-4D97-AF65-F5344CB8AC3E}">
@@ -30774,10 +30549,8 @@
               <a:t>Bernoulli </a:t>
             </a:r>
             <a:r>
-              <a:rPr lang="en-US" sz="2600" dirty="0">
-                <a:sym typeface="Wingdings"/>
-              </a:rPr>
-              <a:t> probability a single coin flip comes up heads</a:t>
+              <a:rPr lang="en-US" sz="2600" dirty="0"/>
+              <a:t>→ probability a single coin flip comes up heads</a:t>
             </a:r>
           </a:p>
           <a:p>
@@ -30788,10 +30561,8 @@
               <a:defRPr/>
             </a:pPr>
             <a:r>
-              <a:rPr lang="en-US" sz="2600" dirty="0">
-                <a:sym typeface="Wingdings"/>
-              </a:rPr>
-              <a:t>Binomial  Probability that 10 coin flips yield 3 heads</a:t>
+              <a:rPr lang="en-US" sz="2600" dirty="0"/>
+              <a:t>Binomial → Probability that 10 coin flips yield 3 heads</a:t>
             </a:r>
           </a:p>
           <a:p>
@@ -30829,77 +30600,103 @@
           </a:p>
         </p:txBody>
       </p:sp>
-      <p:graphicFrame>
-        <p:nvGraphicFramePr>
-          <p:cNvPr id="147459" name="Object 4"/>
-          <p:cNvGraphicFramePr>
-            <a:graphicFrameLocks noGrp="1" noChangeAspect="1"/>
-          </p:cNvGraphicFramePr>
-          <p:nvPr>
-            <p:ph sz="half" idx="2"/>
-            <p:extLst>
-              <p:ext uri="{D42A27DB-BD31-4B8C-83A1-F6EECF244321}">
-                <p14:modId xmlns:p14="http://schemas.microsoft.com/office/powerpoint/2010/main" val="1561546922"/>
-              </p:ext>
-            </p:extLst>
-          </p:nvPr>
-        </p:nvGraphicFramePr>
-        <p:xfrm>
-          <a:off x="3703003" y="1617028"/>
-          <a:ext cx="4573752" cy="828992"/>
-        </p:xfrm>
-        <a:graphic>
-          <a:graphicData uri="http://schemas.openxmlformats.org/presentationml/2006/ole">
-            <mc:AlternateContent xmlns:mc="http://schemas.openxmlformats.org/markup-compatibility/2006">
-              <mc:Choice xmlns:v="urn:schemas-microsoft-com:vml" Requires="v">
-                <p:oleObj name="Equation" r:id="rId3" imgW="2311078" imgH="418893" progId="">
-                  <p:embed/>
-                </p:oleObj>
-              </mc:Choice>
-              <mc:Fallback>
-                <p:oleObj name="Equation" r:id="rId3" imgW="2311078" imgH="418893" progId="">
-                  <p:embed/>
-                  <p:pic>
-                    <p:nvPicPr>
-                      <p:cNvPr id="0" name=""/>
-                      <p:cNvPicPr>
-                        <a:picLocks noGrp="1" noChangeAspect="1" noChangeArrowheads="1"/>
-                      </p:cNvPicPr>
-                      <p:nvPr/>
-                    </p:nvPicPr>
-                    <p:blipFill>
-                      <a:blip r:embed="rId4">
-                        <a:extLst>
-                          <a:ext uri="{28A0092B-C50C-407E-A947-70E740481C1C}">
-                            <a14:useLocalDpi xmlns:a14="http://schemas.microsoft.com/office/drawing/2010/main" val="0"/>
-                          </a:ext>
-                        </a:extLst>
-                      </a:blip>
-                      <a:srcRect/>
-                      <a:stretch>
-                        <a:fillRect/>
-                      </a:stretch>
-                    </p:blipFill>
-                    <p:spPr bwMode="auto">
-                      <a:xfrm>
-                        <a:off x="3703003" y="1617028"/>
-                        <a:ext cx="4573752" cy="828992"/>
-                      </a:xfrm>
-                      <a:prstGeom prst="rect">
-                        <a:avLst/>
-                      </a:prstGeom>
-                      <a:noFill/>
-                      <a:ln>
-                        <a:noFill/>
-                      </a:ln>
-                    </p:spPr>
-                  </p:pic>
-                </p:oleObj>
-              </mc:Fallback>
-            </mc:AlternateContent>
-          </a:graphicData>
-        </a:graphic>
-      </p:graphicFrame>
+      <p:sp>
+        <p:nvSpPr>
+          <p:cNvPr id="7172" name="TextBox 7171"/>
+          <p:cNvSpPr txBox="1"/>
+          <p:nvPr/>
+        </p:nvSpPr>
+        <p:spPr>
+          <a:xfrm>
+            <a:off x="3703003" y="1617028"/>
+            <a:ext cx="6893169" cy="828992"/>
+          </a:xfrm>
+          <a:prstGeom prst="rect">
+            <a:avLst/>
+          </a:prstGeom>
+          <a:noFill/>
+        </p:spPr>
+        <p:txBody>
+          <a:bodyPr wrap="square" anchor="ctr" lIns="0" rIns="0" tIns="0" bIns="0">
+            <a:spAutoFit/>
+          </a:bodyPr>
+          <a:lstStyle/>
+          <a:p>
+            <a:r>
+              <a:rPr sz="1900">
+                <a:latin typeface="Cambria"/>
+              </a:rPr>
+              <a:t>P(x) = </a:t>
+            </a:r>
+            <a:r>
+              <a:rPr sz="1900" baseline="-25000">
+                <a:latin typeface="Cambria"/>
+              </a:rPr>
+              <a:t>n</a:t>
+            </a:r>
+            <a:r>
+              <a:rPr sz="1900">
+                <a:latin typeface="Cambria"/>
+              </a:rPr>
+              <a:t>C</a:t>
+            </a:r>
+            <a:r>
+              <a:rPr sz="1900" baseline="-25000">
+                <a:latin typeface="Cambria"/>
+              </a:rPr>
+              <a:t>x</a:t>
+            </a:r>
+            <a:r>
+              <a:rPr sz="1900">
+                <a:latin typeface="Cambria"/>
+              </a:rPr>
+              <a:t> p</a:t>
+            </a:r>
+            <a:r>
+              <a:rPr sz="1900" baseline="30000">
+                <a:latin typeface="Cambria"/>
+              </a:rPr>
+              <a:t>x</a:t>
+            </a:r>
+            <a:r>
+              <a:rPr sz="1900">
+                <a:latin typeface="Cambria"/>
+              </a:rPr>
+              <a:t> q</a:t>
+            </a:r>
+            <a:r>
+              <a:rPr sz="1900" baseline="30000">
+                <a:latin typeface="Cambria"/>
+              </a:rPr>
+              <a:t>n−x</a:t>
+            </a:r>
+            <a:r>
+              <a:rPr sz="1900">
+                <a:latin typeface="Cambria"/>
+              </a:rPr>
+              <a:t> = n! / ((n − x)! x!) · p</a:t>
+            </a:r>
+            <a:r>
+              <a:rPr sz="1900" baseline="30000">
+                <a:latin typeface="Cambria"/>
+              </a:rPr>
+              <a:t>x</a:t>
+            </a:r>
+            <a:r>
+              <a:rPr sz="1900">
+                <a:latin typeface="Cambria"/>
+              </a:rPr>
+              <a:t> q</a:t>
+            </a:r>
+            <a:r>
+              <a:rPr sz="1900" baseline="30000">
+                <a:latin typeface="Cambria"/>
+              </a:rPr>
+              <a:t>n−x</a:t>
+            </a:r>
+          </a:p>
+        </p:txBody>
+      </p:sp>
     </p:spTree>
     <p:extLst>
       <p:ext uri="{BB962C8B-B14F-4D97-AF65-F5344CB8AC3E}">

</xml_diff>

<commit_message>
Day 1 accessible: convert pasted content-images (Beamer pages, textbook excerpts) to text
Rebuilds slides whose content was pasted as a picture -- concept questions, worked
solutions, pmf tables and textbook excerpts -- into real text, with pmf/variance tables
as genuine PowerPoint tables so a screen reader can navigate rows and columns. Venn
diagrams and the book cover stay as images with alt text.

Afternoon: slides 7, 8, 9, 10, 40.  Morning: slides 14, 25, 50, 51.

Co-Authored-By: Claude Opus 4.8 <noreply@anthropic.com>
</commit_message>
<xml_diff>
--- a/Day1_Probability/FW536_Day1_Afternoon Distributions I_accessible.pptx
+++ b/Day1_Probability/FW536_Day1_Afternoon Distributions I_accessible.pptx
@@ -7555,35 +7555,481 @@
           <a:chExt cx="0" cy="0"/>
         </a:xfrm>
       </p:grpSpPr>
-      <p:pic>
-        <p:nvPicPr>
-          <p:cNvPr id="2" name="Picture 1" descr="Worked solution. For Bernoulli(p), a table gives Var(X)=E[(X-mu)^2]=(1-p)p^2+p(1-p)^2=p(1-p). For bin(n,p), X is a sum of n independent Bernoulli(p), so variances add: Var(X)=Var(X1)+...+Var(Xn)=np(1-p)." title="Worked solution. For Bernoulli(p), a table gives Var(X)=E[(X-mu)^2]=(1-p)p^2+p(1"/>
-          <p:cNvPicPr>
-            <a:picLocks noChangeAspect="1"/>
-          </p:cNvPicPr>
+      <p:sp>
+        <p:nvSpPr>
+          <p:cNvPr id="2" name="TextBox 1"/>
+          <p:cNvSpPr txBox="1"/>
           <p:nvPr/>
-        </p:nvPicPr>
-        <p:blipFill rotWithShape="1">
-          <a:blip r:embed="rId2">
-            <a:extLst>
-              <a:ext uri="{28A0092B-C50C-407E-A947-70E740481C1C}">
-                <a14:useLocalDpi xmlns:a14="http://schemas.microsoft.com/office/drawing/2010/main" val="0"/>
-              </a:ext>
-            </a:extLst>
-          </a:blip>
-          <a:srcRect b="19073"/>
-          <a:stretch/>
-        </p:blipFill>
+        </p:nvSpPr>
         <p:spPr>
           <a:xfrm>
-            <a:off x="1433285" y="264885"/>
-            <a:ext cx="9533925" cy="5781352"/>
+            <a:off x="1597877" y="429477"/>
+            <a:ext cx="9204741" cy="534924"/>
           </a:xfrm>
           <a:prstGeom prst="rect">
             <a:avLst/>
           </a:prstGeom>
-        </p:spPr>
-      </p:pic>
+          <a:noFill/>
+        </p:spPr>
+        <p:txBody>
+          <a:bodyPr wrap="square" anchor="t" lIns="0" rIns="0" tIns="0" bIns="0">
+            <a:spAutoFit/>
+          </a:bodyPr>
+          <a:lstStyle/>
+          <a:p>
+            <a:r>
+              <a:rPr sz="2800" b="0">
+                <a:solidFill>
+                  <a:srgbClr val="3333CC"/>
+                </a:solidFill>
+                <a:latin typeface="Calibri"/>
+              </a:rPr>
+              <a:t>Solution</a:t>
+            </a:r>
+          </a:p>
+        </p:txBody>
+      </p:sp>
+      <p:sp>
+        <p:nvSpPr>
+          <p:cNvPr id="3" name="TextBox 2"/>
+          <p:cNvSpPr txBox="1"/>
+          <p:nvPr/>
+        </p:nvSpPr>
+        <p:spPr>
+          <a:xfrm>
+            <a:off x="1597877" y="1238721"/>
+            <a:ext cx="9204741" cy="363474"/>
+          </a:xfrm>
+          <a:prstGeom prst="rect">
+            <a:avLst/>
+          </a:prstGeom>
+          <a:noFill/>
+        </p:spPr>
+        <p:txBody>
+          <a:bodyPr wrap="square" anchor="t" lIns="0" rIns="0" tIns="0" bIns="0">
+            <a:spAutoFit/>
+          </a:bodyPr>
+          <a:lstStyle/>
+          <a:p>
+            <a:r>
+              <a:rPr sz="1800" b="0">
+                <a:latin typeface="Calibri"/>
+              </a:rPr>
+              <a:t>1. For X ~ Bernoulli(p) we use a table. (We know E(X) = p.)</a:t>
+            </a:r>
+          </a:p>
+        </p:txBody>
+      </p:sp>
+      <p:graphicFrame>
+        <p:nvGraphicFramePr>
+          <p:cNvPr id="4" name="Table 3"/>
+          <p:cNvGraphicFramePr>
+            <a:graphicFrameLocks noGrp="1"/>
+          </p:cNvGraphicFramePr>
+          <p:nvPr/>
+        </p:nvGraphicFramePr>
+        <p:xfrm>
+          <a:off x="1597877" y="1711923"/>
+          <a:ext cx="4206240" cy="952500"/>
+        </p:xfrm>
+        <a:graphic>
+          <a:graphicData uri="http://schemas.openxmlformats.org/drawingml/2006/table">
+            <a:tbl>
+              <a:tblPr firstCol="1">
+                <a:tableStyleId>{5C22544A-7EE6-4342-B048-85BDC9FD1C3A}</a:tableStyleId>
+              </a:tblPr>
+              <a:tblGrid>
+                <a:gridCol w="1402080"/>
+                <a:gridCol w="1402080"/>
+                <a:gridCol w="1402080"/>
+              </a:tblGrid>
+              <a:tr h="317500">
+                <a:tc>
+                  <a:txBody>
+                    <a:bodyPr wrap="none" lIns="27432" rIns="27432" tIns="27432" bIns="27432"/>
+                    <a:lstStyle/>
+                    <a:p>
+                      <a:pPr algn="r"/>
+                      <a:r>
+                        <a:rPr sz="1500" b="1">
+                          <a:latin typeface="Cambria"/>
+                        </a:rPr>
+                        <a:t>X</a:t>
+                      </a:r>
+                    </a:p>
+                  </a:txBody>
+                  <a:tcPr/>
+                </a:tc>
+                <a:tc>
+                  <a:txBody>
+                    <a:bodyPr wrap="none" lIns="27432" rIns="27432" tIns="27432" bIns="27432"/>
+                    <a:lstStyle/>
+                    <a:p>
+                      <a:pPr algn="ctr"/>
+                      <a:r>
+                        <a:rPr sz="1500" b="0">
+                          <a:latin typeface="Cambria"/>
+                        </a:rPr>
+                        <a:t>0</a:t>
+                      </a:r>
+                    </a:p>
+                  </a:txBody>
+                  <a:tcPr/>
+                </a:tc>
+                <a:tc>
+                  <a:txBody>
+                    <a:bodyPr wrap="none" lIns="27432" rIns="27432" tIns="27432" bIns="27432"/>
+                    <a:lstStyle/>
+                    <a:p>
+                      <a:pPr algn="ctr"/>
+                      <a:r>
+                        <a:rPr sz="1500" b="0">
+                          <a:latin typeface="Cambria"/>
+                        </a:rPr>
+                        <a:t>1</a:t>
+                      </a:r>
+                    </a:p>
+                  </a:txBody>
+                  <a:tcPr/>
+                </a:tc>
+              </a:tr>
+              <a:tr h="317500">
+                <a:tc>
+                  <a:txBody>
+                    <a:bodyPr wrap="none" lIns="27432" rIns="27432" tIns="27432" bIns="27432"/>
+                    <a:lstStyle/>
+                    <a:p>
+                      <a:pPr algn="r"/>
+                      <a:r>
+                        <a:rPr sz="1500" b="1">
+                          <a:latin typeface="Cambria"/>
+                        </a:rPr>
+                        <a:t>p(x)</a:t>
+                      </a:r>
+                    </a:p>
+                  </a:txBody>
+                  <a:tcPr/>
+                </a:tc>
+                <a:tc>
+                  <a:txBody>
+                    <a:bodyPr wrap="none" lIns="27432" rIns="27432" tIns="27432" bIns="27432"/>
+                    <a:lstStyle/>
+                    <a:p>
+                      <a:pPr algn="ctr"/>
+                      <a:r>
+                        <a:rPr sz="1500" b="0">
+                          <a:latin typeface="Cambria"/>
+                        </a:rPr>
+                        <a:t>1 − p</a:t>
+                      </a:r>
+                    </a:p>
+                  </a:txBody>
+                  <a:tcPr/>
+                </a:tc>
+                <a:tc>
+                  <a:txBody>
+                    <a:bodyPr wrap="none" lIns="27432" rIns="27432" tIns="27432" bIns="27432"/>
+                    <a:lstStyle/>
+                    <a:p>
+                      <a:pPr algn="ctr"/>
+                      <a:r>
+                        <a:rPr sz="1500" b="0">
+                          <a:latin typeface="Cambria"/>
+                        </a:rPr>
+                        <a:t>p</a:t>
+                      </a:r>
+                    </a:p>
+                  </a:txBody>
+                  <a:tcPr/>
+                </a:tc>
+              </a:tr>
+              <a:tr h="317500">
+                <a:tc>
+                  <a:txBody>
+                    <a:bodyPr wrap="none" lIns="27432" rIns="27432" tIns="27432" bIns="27432"/>
+                    <a:lstStyle/>
+                    <a:p>
+                      <a:pPr algn="r"/>
+                      <a:r>
+                        <a:rPr sz="1500" b="1">
+                          <a:latin typeface="Cambria"/>
+                        </a:rPr>
+                        <a:t>(X − μ)</a:t>
+                      </a:r>
+                      <a:r>
+                        <a:rPr sz="1500" b="1" baseline="30000">
+                          <a:latin typeface="Cambria"/>
+                        </a:rPr>
+                        <a:t>2</a:t>
+                      </a:r>
+                    </a:p>
+                  </a:txBody>
+                  <a:tcPr/>
+                </a:tc>
+                <a:tc>
+                  <a:txBody>
+                    <a:bodyPr wrap="none" lIns="27432" rIns="27432" tIns="27432" bIns="27432"/>
+                    <a:lstStyle/>
+                    <a:p>
+                      <a:pPr algn="ctr"/>
+                      <a:r>
+                        <a:rPr sz="1500" b="0">
+                          <a:latin typeface="Cambria"/>
+                        </a:rPr>
+                        <a:t>p</a:t>
+                      </a:r>
+                      <a:r>
+                        <a:rPr sz="1500" b="0" baseline="30000">
+                          <a:latin typeface="Cambria"/>
+                        </a:rPr>
+                        <a:t>2</a:t>
+                      </a:r>
+                    </a:p>
+                  </a:txBody>
+                  <a:tcPr/>
+                </a:tc>
+                <a:tc>
+                  <a:txBody>
+                    <a:bodyPr wrap="none" lIns="27432" rIns="27432" tIns="27432" bIns="27432"/>
+                    <a:lstStyle/>
+                    <a:p>
+                      <a:pPr algn="ctr"/>
+                      <a:r>
+                        <a:rPr sz="1500" b="0">
+                          <a:latin typeface="Cambria"/>
+                        </a:rPr>
+                        <a:t>(1 − p)</a:t>
+                      </a:r>
+                      <a:r>
+                        <a:rPr sz="1500" b="0" baseline="30000">
+                          <a:latin typeface="Cambria"/>
+                        </a:rPr>
+                        <a:t>2</a:t>
+                      </a:r>
+                    </a:p>
+                  </a:txBody>
+                  <a:tcPr/>
+                </a:tc>
+              </a:tr>
+            </a:tbl>
+          </a:graphicData>
+        </a:graphic>
+      </p:graphicFrame>
+      <p:sp>
+        <p:nvSpPr>
+          <p:cNvPr id="5" name="TextBox 4"/>
+          <p:cNvSpPr txBox="1"/>
+          <p:nvPr/>
+        </p:nvSpPr>
+        <p:spPr>
+          <a:xfrm>
+            <a:off x="1597877" y="2810727"/>
+            <a:ext cx="9204741" cy="346329"/>
+          </a:xfrm>
+          <a:prstGeom prst="rect">
+            <a:avLst/>
+          </a:prstGeom>
+          <a:noFill/>
+        </p:spPr>
+        <p:txBody>
+          <a:bodyPr wrap="square" anchor="t" lIns="0" rIns="0" tIns="0" bIns="0">
+            <a:spAutoFit/>
+          </a:bodyPr>
+          <a:lstStyle/>
+          <a:p>
+            <a:pPr algn="ctr"/>
+            <a:r>
+              <a:rPr sz="1700" b="0">
+                <a:latin typeface="Cambria"/>
+              </a:rPr>
+              <a:t>Var(X) = E((X − μ)</a:t>
+            </a:r>
+            <a:r>
+              <a:rPr sz="1700" b="0" baseline="30000">
+                <a:latin typeface="Cambria"/>
+              </a:rPr>
+              <a:t>2</a:t>
+            </a:r>
+            <a:r>
+              <a:rPr sz="1700" b="0">
+                <a:latin typeface="Cambria"/>
+              </a:rPr>
+              <a:t>) = (1 − p)p</a:t>
+            </a:r>
+            <a:r>
+              <a:rPr sz="1700" b="0" baseline="30000">
+                <a:latin typeface="Cambria"/>
+              </a:rPr>
+              <a:t>2</a:t>
+            </a:r>
+            <a:r>
+              <a:rPr sz="1700" b="0">
+                <a:latin typeface="Cambria"/>
+              </a:rPr>
+              <a:t> + p(1 − p)</a:t>
+            </a:r>
+            <a:r>
+              <a:rPr sz="1700" b="0" baseline="30000">
+                <a:latin typeface="Cambria"/>
+              </a:rPr>
+              <a:t>2</a:t>
+            </a:r>
+            <a:r>
+              <a:rPr sz="1700" b="0">
+                <a:latin typeface="Cambria"/>
+              </a:rPr>
+              <a:t> = p(1 − p)</a:t>
+            </a:r>
+          </a:p>
+        </p:txBody>
+      </p:sp>
+      <p:sp>
+        <p:nvSpPr>
+          <p:cNvPr id="6" name="TextBox 5"/>
+          <p:cNvSpPr txBox="1"/>
+          <p:nvPr/>
+        </p:nvSpPr>
+        <p:spPr>
+          <a:xfrm>
+            <a:off x="1597877" y="3431376"/>
+            <a:ext cx="9204741" cy="672084"/>
+          </a:xfrm>
+          <a:prstGeom prst="rect">
+            <a:avLst/>
+          </a:prstGeom>
+          <a:noFill/>
+        </p:spPr>
+        <p:txBody>
+          <a:bodyPr wrap="square" anchor="t" lIns="0" rIns="0" tIns="0" bIns="0">
+            <a:spAutoFit/>
+          </a:bodyPr>
+          <a:lstStyle/>
+          <a:p>
+            <a:r>
+              <a:rPr sz="1800" b="0">
+                <a:latin typeface="Calibri"/>
+              </a:rPr>
+              <a:t>2. X ~ bin(n, p) means X is the sum of n independent Bernoulli(p) random variables X</a:t>
+            </a:r>
+            <a:r>
+              <a:rPr sz="1800" b="0" baseline="-25000">
+                <a:latin typeface="Calibri"/>
+              </a:rPr>
+              <a:t>1</a:t>
+            </a:r>
+            <a:r>
+              <a:rPr sz="1800" b="0">
+                <a:latin typeface="Calibri"/>
+              </a:rPr>
+              <a:t>, X</a:t>
+            </a:r>
+            <a:r>
+              <a:rPr sz="1800" b="0" baseline="-25000">
+                <a:latin typeface="Calibri"/>
+              </a:rPr>
+              <a:t>2</a:t>
+            </a:r>
+            <a:r>
+              <a:rPr sz="1800" b="0">
+                <a:latin typeface="Calibri"/>
+              </a:rPr>
+              <a:t>, …, X</a:t>
+            </a:r>
+            <a:r>
+              <a:rPr sz="1800" b="0" baseline="-25000">
+                <a:latin typeface="Calibri"/>
+              </a:rPr>
+              <a:t>n</a:t>
+            </a:r>
+            <a:r>
+              <a:rPr sz="1800" b="0">
+                <a:latin typeface="Calibri"/>
+              </a:rPr>
+              <a:t>. For independent variables, the variances add. Since Var(X</a:t>
+            </a:r>
+            <a:r>
+              <a:rPr sz="1800" b="0" baseline="-25000">
+                <a:latin typeface="Calibri"/>
+              </a:rPr>
+              <a:t>j</a:t>
+            </a:r>
+            <a:r>
+              <a:rPr sz="1800" b="0">
+                <a:latin typeface="Calibri"/>
+              </a:rPr>
+              <a:t>) = p(1 − p) we have</a:t>
+            </a:r>
+          </a:p>
+        </p:txBody>
+      </p:sp>
+      <p:sp>
+        <p:nvSpPr>
+          <p:cNvPr id="7" name="TextBox 6"/>
+          <p:cNvSpPr txBox="1"/>
+          <p:nvPr/>
+        </p:nvSpPr>
+        <p:spPr>
+          <a:xfrm>
+            <a:off x="1597877" y="4249764"/>
+            <a:ext cx="9204741" cy="346329"/>
+          </a:xfrm>
+          <a:prstGeom prst="rect">
+            <a:avLst/>
+          </a:prstGeom>
+          <a:noFill/>
+        </p:spPr>
+        <p:txBody>
+          <a:bodyPr wrap="square" anchor="t" lIns="0" rIns="0" tIns="0" bIns="0">
+            <a:spAutoFit/>
+          </a:bodyPr>
+          <a:lstStyle/>
+          <a:p>
+            <a:pPr algn="ctr"/>
+            <a:r>
+              <a:rPr sz="1700" b="0">
+                <a:latin typeface="Cambria"/>
+              </a:rPr>
+              <a:t>Var(X) = Var(X</a:t>
+            </a:r>
+            <a:r>
+              <a:rPr sz="1700" b="0" baseline="-25000">
+                <a:latin typeface="Cambria"/>
+              </a:rPr>
+              <a:t>1</a:t>
+            </a:r>
+            <a:r>
+              <a:rPr sz="1700" b="0">
+                <a:latin typeface="Cambria"/>
+              </a:rPr>
+              <a:t>) + Var(X</a:t>
+            </a:r>
+            <a:r>
+              <a:rPr sz="1700" b="0" baseline="-25000">
+                <a:latin typeface="Cambria"/>
+              </a:rPr>
+              <a:t>2</a:t>
+            </a:r>
+            <a:r>
+              <a:rPr sz="1700" b="0">
+                <a:latin typeface="Cambria"/>
+              </a:rPr>
+              <a:t>) + … + Var(X</a:t>
+            </a:r>
+            <a:r>
+              <a:rPr sz="1700" b="0" baseline="-25000">
+                <a:latin typeface="Cambria"/>
+              </a:rPr>
+              <a:t>n</a:t>
+            </a:r>
+            <a:r>
+              <a:rPr sz="1700" b="0">
+                <a:latin typeface="Cambria"/>
+              </a:rPr>
+              <a:t>) = np(p − 1).</a:t>
+            </a:r>
+          </a:p>
+        </p:txBody>
+      </p:sp>
     </p:spTree>
     <p:extLst>
       <p:ext uri="{BB962C8B-B14F-4D97-AF65-F5344CB8AC3E}">
@@ -21671,60 +22117,6 @@
           <a:chExt cx="0" cy="0"/>
         </a:xfrm>
       </p:grpSpPr>
-      <p:pic>
-        <p:nvPicPr>
-          <p:cNvPr id="211971" name="Picture 3" descr="Text: for the kth success on trial n, we need k-1 successes in the first n-1 trials (binomial with parameters n-1 and p) and a success on trial n with probability p, independently." title="Text: for the kth success on trial n, we need k-1 successes in the first n-1 tri"/>
-          <p:cNvPicPr>
-            <a:picLocks noChangeAspect="1"/>
-          </p:cNvPicPr>
-          <p:nvPr/>
-        </p:nvPicPr>
-        <p:blipFill>
-          <a:blip r:embed="rId4">
-            <a:extLst>
-              <a:ext uri="{28A0092B-C50C-407E-A947-70E740481C1C}">
-                <a14:useLocalDpi xmlns:a14="http://schemas.microsoft.com/office/drawing/2010/main" val="0"/>
-              </a:ext>
-            </a:extLst>
-          </a:blip>
-          <a:srcRect/>
-          <a:stretch>
-            <a:fillRect/>
-          </a:stretch>
-        </p:blipFill>
-        <p:spPr bwMode="auto">
-          <a:xfrm>
-            <a:off x="1524000" y="2046622"/>
-            <a:ext cx="9144000" cy="2724150"/>
-          </a:xfrm>
-          <a:prstGeom prst="rect">
-            <a:avLst/>
-          </a:prstGeom>
-          <a:noFill/>
-          <a:ln>
-            <a:noFill/>
-          </a:ln>
-          <a:extLst>
-            <a:ext uri="{909E8E84-426E-40DD-AFC4-6F175D3DCCD1}">
-              <a14:hiddenFill xmlns:a14="http://schemas.microsoft.com/office/drawing/2010/main">
-                <a:solidFill>
-                  <a:srgbClr val="FFFFFF"/>
-                </a:solidFill>
-              </a14:hiddenFill>
-            </a:ext>
-            <a:ext uri="{91240B29-F687-4F45-9708-019B960494DF}">
-              <a14:hiddenLine xmlns:a14="http://schemas.microsoft.com/office/drawing/2010/main" w="9525">
-                <a:solidFill>
-                  <a:srgbClr val="000000"/>
-                </a:solidFill>
-                <a:miter lim="800000"/>
-                <a:headEnd/>
-                <a:tailEnd/>
-              </a14:hiddenLine>
-            </a:ext>
-          </a:extLst>
-        </p:spPr>
-      </p:pic>
       <p:sp>
         <p:nvSpPr>
           <p:cNvPr id="211973" name="TextBox 6"/>
@@ -22190,6 +22582,37 @@
                 <a:latin typeface="Cambria"/>
               </a:rPr>
               <a:t>r</a:t>
+            </a:r>
+          </a:p>
+        </p:txBody>
+      </p:sp>
+      <p:sp>
+        <p:nvSpPr>
+          <p:cNvPr id="211977" name="TextBox 211976"/>
+          <p:cNvSpPr txBox="1"/>
+          <p:nvPr/>
+        </p:nvSpPr>
+        <p:spPr>
+          <a:xfrm>
+            <a:off x="1688592" y="2211214"/>
+            <a:ext cx="8814816" cy="1289304"/>
+          </a:xfrm>
+          <a:prstGeom prst="rect">
+            <a:avLst/>
+          </a:prstGeom>
+          <a:noFill/>
+        </p:spPr>
+        <p:txBody>
+          <a:bodyPr wrap="square" anchor="t" lIns="0" rIns="0" tIns="0" bIns="0">
+            <a:spAutoFit/>
+          </a:bodyPr>
+          <a:lstStyle/>
+          <a:p>
+            <a:r>
+              <a:rPr sz="1800" b="0">
+                <a:latin typeface="Calibri"/>
+              </a:rPr>
+              <a:t>Now, for the kth success to occur on trial n, we must have k − 1 successes in the first n − 1 trials and a success on the nth trial. The probability of k − 1 successes in n − 1 trials has a binomial distribution with parameters n − 1 and p and the probability of success on the nth trial has probability p and these are independent of each other. We thus conclude</a:t>
             </a:r>
           </a:p>
         </p:txBody>
@@ -30886,35 +31309,180 @@
           <a:chExt cx="0" cy="0"/>
         </a:xfrm>
       </p:grpSpPr>
-      <p:pic>
-        <p:nvPicPr>
-          <p:cNvPr id="7" name="Picture 6" descr="Concept-question slide. Q1: if X~binom(n,p) and Y~binom(m,p) are independent, X+Y follows (a) binom(n+m,p), (b) binom(nm,p), (c) binom(n+m,2p), (d) other. Q2: X~binom(n,p) and Z~binom(n,q) independent, X+Z follows (a) binom(n,p+q), (b) binom(n,pq), (c) binom(2n,p+q), (d) other." title="Concept-question slide. Q1: if X~binom(n,p) and Y~binom(m,p) are independent, X+"/>
-          <p:cNvPicPr>
-            <a:picLocks noChangeAspect="1"/>
-          </p:cNvPicPr>
+      <p:sp>
+        <p:nvSpPr>
+          <p:cNvPr id="2" name="TextBox 1"/>
+          <p:cNvSpPr txBox="1"/>
           <p:nvPr/>
-        </p:nvPicPr>
-        <p:blipFill rotWithShape="1">
-          <a:blip r:embed="rId2">
-            <a:extLst>
-              <a:ext uri="{28A0092B-C50C-407E-A947-70E740481C1C}">
-                <a14:useLocalDpi xmlns:a14="http://schemas.microsoft.com/office/drawing/2010/main" val="0"/>
-              </a:ext>
-            </a:extLst>
-          </a:blip>
-          <a:srcRect b="14507"/>
-          <a:stretch/>
-        </p:blipFill>
+        </p:nvSpPr>
         <p:spPr>
           <a:xfrm>
-            <a:off x="1363335" y="0"/>
-            <a:ext cx="9758680" cy="6251510"/>
+            <a:off x="1527927" y="164592"/>
+            <a:ext cx="9429496" cy="569214"/>
           </a:xfrm>
           <a:prstGeom prst="rect">
             <a:avLst/>
           </a:prstGeom>
-        </p:spPr>
-      </p:pic>
+          <a:noFill/>
+        </p:spPr>
+        <p:txBody>
+          <a:bodyPr wrap="square" anchor="t" lIns="0" rIns="0" tIns="0" bIns="0">
+            <a:spAutoFit/>
+          </a:bodyPr>
+          <a:lstStyle/>
+          <a:p>
+            <a:r>
+              <a:rPr sz="3000" b="0">
+                <a:solidFill>
+                  <a:srgbClr val="3333CC"/>
+                </a:solidFill>
+                <a:latin typeface="Calibri"/>
+              </a:rPr>
+              <a:t>Concept Question</a:t>
+            </a:r>
+          </a:p>
+        </p:txBody>
+      </p:sp>
+      <p:sp>
+        <p:nvSpPr>
+          <p:cNvPr id="3" name="TextBox 2"/>
+          <p:cNvSpPr txBox="1"/>
+          <p:nvPr/>
+        </p:nvSpPr>
+        <p:spPr>
+          <a:xfrm>
+            <a:off x="1527927" y="1044702"/>
+            <a:ext cx="9429496" cy="397764"/>
+          </a:xfrm>
+          <a:prstGeom prst="rect">
+            <a:avLst/>
+          </a:prstGeom>
+          <a:noFill/>
+        </p:spPr>
+        <p:txBody>
+          <a:bodyPr wrap="square" anchor="t" lIns="0" rIns="0" tIns="0" bIns="0">
+            <a:spAutoFit/>
+          </a:bodyPr>
+          <a:lstStyle/>
+          <a:p>
+            <a:r>
+              <a:rPr sz="2000" b="0">
+                <a:latin typeface="Calibri"/>
+              </a:rPr>
+              <a:t>1. Let X ~ binom(n, p) and Y ~ binom(m, p) be independent. Then X + Y follows:</a:t>
+            </a:r>
+          </a:p>
+        </p:txBody>
+      </p:sp>
+      <p:sp>
+        <p:nvSpPr>
+          <p:cNvPr id="4" name="TextBox 3"/>
+          <p:cNvSpPr txBox="1"/>
+          <p:nvPr/>
+        </p:nvSpPr>
+        <p:spPr>
+          <a:xfrm>
+            <a:off x="1527927" y="1533906"/>
+            <a:ext cx="9429496" cy="740664"/>
+          </a:xfrm>
+          <a:prstGeom prst="rect">
+            <a:avLst/>
+          </a:prstGeom>
+          <a:noFill/>
+        </p:spPr>
+        <p:txBody>
+          <a:bodyPr wrap="square" anchor="t" lIns="0" rIns="0" tIns="0" bIns="0">
+            <a:spAutoFit/>
+          </a:bodyPr>
+          <a:lstStyle/>
+          <a:p>
+            <a:r>
+              <a:rPr sz="2000" b="0">
+                <a:latin typeface="Calibri"/>
+              </a:rPr>
+              <a:t>(a) binom(n + m, p)        (b) binom(nm, p)</a:t>
+            </a:r>
+          </a:p>
+          <a:p>
+            <a:r>
+              <a:rPr sz="2000" b="0">
+                <a:latin typeface="Calibri"/>
+              </a:rPr>
+              <a:t>(c) binom(n + m, 2p)      (d) other</a:t>
+            </a:r>
+          </a:p>
+        </p:txBody>
+      </p:sp>
+      <p:sp>
+        <p:nvSpPr>
+          <p:cNvPr id="5" name="TextBox 4"/>
+          <p:cNvSpPr txBox="1"/>
+          <p:nvPr/>
+        </p:nvSpPr>
+        <p:spPr>
+          <a:xfrm>
+            <a:off x="1527927" y="2585466"/>
+            <a:ext cx="9429496" cy="397764"/>
+          </a:xfrm>
+          <a:prstGeom prst="rect">
+            <a:avLst/>
+          </a:prstGeom>
+          <a:noFill/>
+        </p:spPr>
+        <p:txBody>
+          <a:bodyPr wrap="square" anchor="t" lIns="0" rIns="0" tIns="0" bIns="0">
+            <a:spAutoFit/>
+          </a:bodyPr>
+          <a:lstStyle/>
+          <a:p>
+            <a:r>
+              <a:rPr sz="2000" b="0">
+                <a:latin typeface="Calibri"/>
+              </a:rPr>
+              <a:t>2. Let X ~ binom(n, p) and Z ~ binom(n, q) be independent. Then X + Z follows:</a:t>
+            </a:r>
+          </a:p>
+        </p:txBody>
+      </p:sp>
+      <p:sp>
+        <p:nvSpPr>
+          <p:cNvPr id="6" name="TextBox 5"/>
+          <p:cNvSpPr txBox="1"/>
+          <p:nvPr/>
+        </p:nvSpPr>
+        <p:spPr>
+          <a:xfrm>
+            <a:off x="1527927" y="3074670"/>
+            <a:ext cx="9429496" cy="740664"/>
+          </a:xfrm>
+          <a:prstGeom prst="rect">
+            <a:avLst/>
+          </a:prstGeom>
+          <a:noFill/>
+        </p:spPr>
+        <p:txBody>
+          <a:bodyPr wrap="square" anchor="t" lIns="0" rIns="0" tIns="0" bIns="0">
+            <a:spAutoFit/>
+          </a:bodyPr>
+          <a:lstStyle/>
+          <a:p>
+            <a:r>
+              <a:rPr sz="2000" b="0">
+                <a:latin typeface="Calibri"/>
+              </a:rPr>
+              <a:t>(a) binom(n, p + q)        (b) binom(n, pq)</a:t>
+            </a:r>
+          </a:p>
+          <a:p>
+            <a:r>
+              <a:rPr sz="2000" b="0">
+                <a:latin typeface="Calibri"/>
+              </a:rPr>
+              <a:t>(c) binom(2n, p + q)      (d) other</a:t>
+            </a:r>
+          </a:p>
+        </p:txBody>
+      </p:sp>
     </p:spTree>
     <p:extLst>
       <p:ext uri="{BB962C8B-B14F-4D97-AF65-F5344CB8AC3E}">
@@ -30945,35 +31513,242 @@
           <a:chExt cx="0" cy="0"/>
         </a:xfrm>
       </p:grpSpPr>
-      <p:pic>
-        <p:nvPicPr>
-          <p:cNvPr id="6" name="Picture 5" descr="Same concept question with answers. Q1 answer: (a) binom(n+m,p), since each binomial is a sum of independent Bernoulli(p) variables. Q2 answer: (d) other, because combining Bernoulli(p) with Bernoulli(q) gives no named distribution." title="Same concept question with answers. Q1 answer: (a) binom(n+m,p), since each bino"/>
-          <p:cNvPicPr>
-            <a:picLocks noChangeAspect="1"/>
-          </p:cNvPicPr>
+      <p:sp>
+        <p:nvSpPr>
+          <p:cNvPr id="2" name="TextBox 1"/>
+          <p:cNvSpPr txBox="1"/>
           <p:nvPr/>
-        </p:nvPicPr>
-        <p:blipFill rotWithShape="1">
-          <a:blip r:embed="rId2">
-            <a:extLst>
-              <a:ext uri="{28A0092B-C50C-407E-A947-70E740481C1C}">
-                <a14:useLocalDpi xmlns:a14="http://schemas.microsoft.com/office/drawing/2010/main" val="0"/>
-              </a:ext>
-            </a:extLst>
-          </a:blip>
-          <a:srcRect b="3376"/>
-          <a:stretch/>
-        </p:blipFill>
+        </p:nvSpPr>
         <p:spPr>
           <a:xfrm>
-            <a:off x="1489269" y="134256"/>
-            <a:ext cx="8681098" cy="6285205"/>
+            <a:off x="1653860" y="298848"/>
+            <a:ext cx="8351914" cy="500634"/>
           </a:xfrm>
           <a:prstGeom prst="rect">
             <a:avLst/>
           </a:prstGeom>
-        </p:spPr>
-      </p:pic>
+          <a:noFill/>
+        </p:spPr>
+        <p:txBody>
+          <a:bodyPr wrap="square" anchor="t" lIns="0" rIns="0" tIns="0" bIns="0">
+            <a:spAutoFit/>
+          </a:bodyPr>
+          <a:lstStyle/>
+          <a:p>
+            <a:r>
+              <a:rPr sz="2600" b="0">
+                <a:solidFill>
+                  <a:srgbClr val="3333CC"/>
+                </a:solidFill>
+                <a:latin typeface="Calibri"/>
+              </a:rPr>
+              <a:t>Concept Question</a:t>
+            </a:r>
+          </a:p>
+        </p:txBody>
+      </p:sp>
+      <p:sp>
+        <p:nvSpPr>
+          <p:cNvPr id="3" name="TextBox 2"/>
+          <p:cNvSpPr txBox="1"/>
+          <p:nvPr/>
+        </p:nvSpPr>
+        <p:spPr>
+          <a:xfrm>
+            <a:off x="1653860" y="1000650"/>
+            <a:ext cx="8351914" cy="346329"/>
+          </a:xfrm>
+          <a:prstGeom prst="rect">
+            <a:avLst/>
+          </a:prstGeom>
+          <a:noFill/>
+        </p:spPr>
+        <p:txBody>
+          <a:bodyPr wrap="square" anchor="t" lIns="0" rIns="0" tIns="0" bIns="0">
+            <a:spAutoFit/>
+          </a:bodyPr>
+          <a:lstStyle/>
+          <a:p>
+            <a:r>
+              <a:rPr sz="1700" b="0">
+                <a:latin typeface="Calibri"/>
+              </a:rPr>
+              <a:t>1. Let X ~ binom(n, p) and Y ~ binom(m, p) be independent. Then X + Y follows:</a:t>
+            </a:r>
+          </a:p>
+        </p:txBody>
+      </p:sp>
+      <p:sp>
+        <p:nvSpPr>
+          <p:cNvPr id="4" name="TextBox 3"/>
+          <p:cNvSpPr txBox="1"/>
+          <p:nvPr/>
+        </p:nvSpPr>
+        <p:spPr>
+          <a:xfrm>
+            <a:off x="1653860" y="1420131"/>
+            <a:ext cx="8351914" cy="637794"/>
+          </a:xfrm>
+          <a:prstGeom prst="rect">
+            <a:avLst/>
+          </a:prstGeom>
+          <a:noFill/>
+        </p:spPr>
+        <p:txBody>
+          <a:bodyPr wrap="square" anchor="t" lIns="0" rIns="0" tIns="0" bIns="0">
+            <a:spAutoFit/>
+          </a:bodyPr>
+          <a:lstStyle/>
+          <a:p>
+            <a:r>
+              <a:rPr sz="1700" b="0">
+                <a:latin typeface="Calibri"/>
+              </a:rPr>
+              <a:t>(a) binom(n + m, p)        (b) binom(nm, p)</a:t>
+            </a:r>
+          </a:p>
+          <a:p>
+            <a:r>
+              <a:rPr sz="1700" b="0">
+                <a:latin typeface="Calibri"/>
+              </a:rPr>
+              <a:t>(c) binom(n + m, 2p)      (d) other</a:t>
+            </a:r>
+          </a:p>
+        </p:txBody>
+      </p:sp>
+      <p:sp>
+        <p:nvSpPr>
+          <p:cNvPr id="5" name="TextBox 4"/>
+          <p:cNvSpPr txBox="1"/>
+          <p:nvPr/>
+        </p:nvSpPr>
+        <p:spPr>
+          <a:xfrm>
+            <a:off x="1653860" y="2259093"/>
+            <a:ext cx="8351914" cy="346329"/>
+          </a:xfrm>
+          <a:prstGeom prst="rect">
+            <a:avLst/>
+          </a:prstGeom>
+          <a:noFill/>
+        </p:spPr>
+        <p:txBody>
+          <a:bodyPr wrap="square" anchor="t" lIns="0" rIns="0" tIns="0" bIns="0">
+            <a:spAutoFit/>
+          </a:bodyPr>
+          <a:lstStyle/>
+          <a:p>
+            <a:r>
+              <a:rPr sz="1700" b="0">
+                <a:latin typeface="Calibri"/>
+              </a:rPr>
+              <a:t>2. Let X ~ binom(n, p) and Z ~ binom(n, q) be independent. Then X + Z follows:</a:t>
+            </a:r>
+          </a:p>
+        </p:txBody>
+      </p:sp>
+      <p:sp>
+        <p:nvSpPr>
+          <p:cNvPr id="6" name="TextBox 5"/>
+          <p:cNvSpPr txBox="1"/>
+          <p:nvPr/>
+        </p:nvSpPr>
+        <p:spPr>
+          <a:xfrm>
+            <a:off x="1653860" y="2678574"/>
+            <a:ext cx="8351914" cy="637794"/>
+          </a:xfrm>
+          <a:prstGeom prst="rect">
+            <a:avLst/>
+          </a:prstGeom>
+          <a:noFill/>
+        </p:spPr>
+        <p:txBody>
+          <a:bodyPr wrap="square" anchor="t" lIns="0" rIns="0" tIns="0" bIns="0">
+            <a:spAutoFit/>
+          </a:bodyPr>
+          <a:lstStyle/>
+          <a:p>
+            <a:r>
+              <a:rPr sz="1700" b="0">
+                <a:latin typeface="Calibri"/>
+              </a:rPr>
+              <a:t>(a) binom(n, p + q)        (b) binom(n, pq)</a:t>
+            </a:r>
+          </a:p>
+          <a:p>
+            <a:r>
+              <a:rPr sz="1700" b="0">
+                <a:latin typeface="Calibri"/>
+              </a:rPr>
+              <a:t>(c) binom(2n, p + q)      (d) other</a:t>
+            </a:r>
+          </a:p>
+        </p:txBody>
+      </p:sp>
+      <p:sp>
+        <p:nvSpPr>
+          <p:cNvPr id="7" name="TextBox 6"/>
+          <p:cNvSpPr txBox="1"/>
+          <p:nvPr/>
+        </p:nvSpPr>
+        <p:spPr>
+          <a:xfrm>
+            <a:off x="1653860" y="3517536"/>
+            <a:ext cx="8351914" cy="569214"/>
+          </a:xfrm>
+          <a:prstGeom prst="rect">
+            <a:avLst/>
+          </a:prstGeom>
+          <a:noFill/>
+        </p:spPr>
+        <p:txBody>
+          <a:bodyPr wrap="square" anchor="t" lIns="0" rIns="0" tIns="0" bIns="0">
+            <a:spAutoFit/>
+          </a:bodyPr>
+          <a:lstStyle/>
+          <a:p>
+            <a:r>
+              <a:rPr sz="1500" b="0">
+                <a:latin typeface="Calibri"/>
+              </a:rPr>
+              <a:t>1. answer: (a). Each binomial random variable is a sum of independent Bernoulli(p) random variables, so their sum is also a sum of Bernoulli(p) r.v.'s.</a:t>
+            </a:r>
+          </a:p>
+        </p:txBody>
+      </p:sp>
+      <p:sp>
+        <p:nvSpPr>
+          <p:cNvPr id="8" name="TextBox 7"/>
+          <p:cNvSpPr txBox="1"/>
+          <p:nvPr/>
+        </p:nvSpPr>
+        <p:spPr>
+          <a:xfrm>
+            <a:off x="1653860" y="4196478"/>
+            <a:ext cx="8351914" cy="569214"/>
+          </a:xfrm>
+          <a:prstGeom prst="rect">
+            <a:avLst/>
+          </a:prstGeom>
+          <a:noFill/>
+        </p:spPr>
+        <p:txBody>
+          <a:bodyPr wrap="square" anchor="t" lIns="0" rIns="0" tIns="0" bIns="0">
+            <a:spAutoFit/>
+          </a:bodyPr>
+          <a:lstStyle/>
+          <a:p>
+            <a:r>
+              <a:rPr sz="1500" b="0">
+                <a:latin typeface="Calibri"/>
+              </a:rPr>
+              <a:t>2. answer: (d) This is different from problem 1 because we are combining Bernoulli(p) r.v.'s with Bernoulli(q) r.v.'s. This is not one of the named random variables we know about.</a:t>
+            </a:r>
+          </a:p>
+        </p:txBody>
+      </p:sp>
     </p:spTree>
     <p:extLst>
       <p:ext uri="{BB962C8B-B14F-4D97-AF65-F5344CB8AC3E}">
@@ -31004,35 +31779,6 @@
           <a:chExt cx="0" cy="0"/>
         </a:xfrm>
       </p:grpSpPr>
-      <p:pic>
-        <p:nvPicPr>
-          <p:cNvPr id="6" name="Picture 5" descr="Board questions. 1: Prove Var(X)=p(1-p) if X~Bernoulli(p). 2: Prove Var(X)=np(1-p) if X~bin(n,p). 3: X1..Xn independent with standard deviation sigma=2; find the standard deviation of their average X-bar. Solution on next slide." title="Board questions. 1: Prove Var(X)=p(1-p) if X~Bernoulli(p). 2: Prove Var(X)=np(1-"/>
-          <p:cNvPicPr>
-            <a:picLocks noChangeAspect="1"/>
-          </p:cNvPicPr>
-          <p:nvPr/>
-        </p:nvPicPr>
-        <p:blipFill rotWithShape="1">
-          <a:blip r:embed="rId2">
-            <a:extLst>
-              <a:ext uri="{28A0092B-C50C-407E-A947-70E740481C1C}">
-                <a14:useLocalDpi xmlns:a14="http://schemas.microsoft.com/office/drawing/2010/main" val="0"/>
-              </a:ext>
-            </a:extLst>
-          </a:blip>
-          <a:srcRect t="13882" b="61669"/>
-          <a:stretch/>
-        </p:blipFill>
-        <p:spPr>
-          <a:xfrm>
-            <a:off x="1302657" y="1343608"/>
-            <a:ext cx="9473412" cy="1735494"/>
-          </a:xfrm>
-          <a:prstGeom prst="rect">
-            <a:avLst/>
-          </a:prstGeom>
-        </p:spPr>
-      </p:pic>
       <p:sp>
         <p:nvSpPr>
           <p:cNvPr id="7" name="TextBox 6"/>
@@ -31191,6 +31937,68 @@
                 </a:solidFill>
               </a:rPr>
               <a:t>Group Work</a:t>
+            </a:r>
+          </a:p>
+        </p:txBody>
+      </p:sp>
+      <p:sp>
+        <p:nvSpPr>
+          <p:cNvPr id="8" name="TextBox 7"/>
+          <p:cNvSpPr txBox="1"/>
+          <p:nvPr/>
+        </p:nvSpPr>
+        <p:spPr>
+          <a:xfrm>
+            <a:off x="1467249" y="1508200"/>
+            <a:ext cx="9144228" cy="432054"/>
+          </a:xfrm>
+          <a:prstGeom prst="rect">
+            <a:avLst/>
+          </a:prstGeom>
+          <a:noFill/>
+        </p:spPr>
+        <p:txBody>
+          <a:bodyPr wrap="square" anchor="t" lIns="0" rIns="0" tIns="0" bIns="0">
+            <a:spAutoFit/>
+          </a:bodyPr>
+          <a:lstStyle/>
+          <a:p>
+            <a:r>
+              <a:rPr sz="2200" b="1">
+                <a:latin typeface="Calibri"/>
+              </a:rPr>
+              <a:t>1. Prove: if X ~ Bernoulli(p)  then  Var(X) = p(1 − p).</a:t>
+            </a:r>
+          </a:p>
+        </p:txBody>
+      </p:sp>
+      <p:sp>
+        <p:nvSpPr>
+          <p:cNvPr id="9" name="TextBox 8"/>
+          <p:cNvSpPr txBox="1"/>
+          <p:nvPr/>
+        </p:nvSpPr>
+        <p:spPr>
+          <a:xfrm>
+            <a:off x="1467249" y="2177998"/>
+            <a:ext cx="9144228" cy="432054"/>
+          </a:xfrm>
+          <a:prstGeom prst="rect">
+            <a:avLst/>
+          </a:prstGeom>
+          <a:noFill/>
+        </p:spPr>
+        <p:txBody>
+          <a:bodyPr wrap="square" anchor="t" lIns="0" rIns="0" tIns="0" bIns="0">
+            <a:spAutoFit/>
+          </a:bodyPr>
+          <a:lstStyle/>
+          <a:p>
+            <a:r>
+              <a:rPr sz="2200" b="1">
+                <a:latin typeface="Calibri"/>
+              </a:rPr>
+              <a:t>2. Prove: if X ~ bin(n, p)  then  Var(X) = n p(1 − p).</a:t>
             </a:r>
           </a:p>
         </p:txBody>

</xml_diff>

<commit_message>
Day 1 afternoon accessible: R console images -> real text (output re-run in R), plus S22/S36
Slides 14, 33, 34, 35: the dbinom/dpois/ppois console screenshots are now real monospace
text. The output was regenerated by running the same expressions in R 4.5.1 rather than
transcribed by eye, so every digit is exact by construction (and matches the originals).
Slide 22 (multinomial title/prose/formula) and slide 36 (journal excerpt) rebuilt as text.

Co-Authored-By: Claude Opus 4.8 <noreply@anthropic.com>
</commit_message>
<xml_diff>
--- a/Day1_Probability/FW536_Day1_Afternoon Distributions I_accessible.pptx
+++ b/Day1_Probability/FW536_Day1_Afternoon Distributions I_accessible.pptx
@@ -9873,114 +9873,6 @@
           </a:p>
         </p:txBody>
       </p:sp>
-      <p:pic>
-        <p:nvPicPr>
-          <p:cNvPr id="2" name="Picture 1" descr="R console: 1-pbinom(1,12,0.1) returns 0.3409977, the probability of 2 or more diseased animals out of 12 when p=0.1." title="R console: 1-pbinom(1,12,0.1) returns 0.3409977, the probability of 2 or more di"/>
-          <p:cNvPicPr>
-            <a:picLocks noChangeAspect="1"/>
-          </p:cNvPicPr>
-          <p:nvPr/>
-        </p:nvPicPr>
-        <p:blipFill>
-          <a:blip r:embed="rId7">
-            <a:extLst>
-              <a:ext uri="{28A0092B-C50C-407E-A947-70E740481C1C}">
-                <a14:useLocalDpi xmlns:a14="http://schemas.microsoft.com/office/drawing/2010/main" val="0"/>
-              </a:ext>
-            </a:extLst>
-          </a:blip>
-          <a:srcRect/>
-          <a:stretch>
-            <a:fillRect/>
-          </a:stretch>
-        </p:blipFill>
-        <p:spPr bwMode="auto">
-          <a:xfrm>
-            <a:off x="4038600" y="6029325"/>
-            <a:ext cx="2743200" cy="609600"/>
-          </a:xfrm>
-          <a:prstGeom prst="rect">
-            <a:avLst/>
-          </a:prstGeom>
-          <a:noFill/>
-          <a:ln>
-            <a:noFill/>
-          </a:ln>
-          <a:extLst>
-            <a:ext uri="{909E8E84-426E-40DD-AFC4-6F175D3DCCD1}">
-              <a14:hiddenFill xmlns:a14="http://schemas.microsoft.com/office/drawing/2010/main">
-                <a:solidFill>
-                  <a:srgbClr val="FFFFFF"/>
-                </a:solidFill>
-              </a14:hiddenFill>
-            </a:ext>
-            <a:ext uri="{91240B29-F687-4F45-9708-019B960494DF}">
-              <a14:hiddenLine xmlns:a14="http://schemas.microsoft.com/office/drawing/2010/main" w="9525">
-                <a:solidFill>
-                  <a:srgbClr val="000000"/>
-                </a:solidFill>
-                <a:miter lim="800000"/>
-                <a:headEnd/>
-                <a:tailEnd/>
-              </a14:hiddenLine>
-            </a:ext>
-          </a:extLst>
-        </p:spPr>
-      </p:pic>
-      <p:pic>
-        <p:nvPicPr>
-          <p:cNvPr id="3" name="Picture 2" descr="R console: dbinom(2,12,0.1)=0.2301278; dbinom(0,12,0.1)=0.2824295; 1-dbinom(1,12,0.1)-dbinom(0,12,0.1)=0.3409977, giving P(exactly 2), P(0), and P(2 or more)." title="R console: dbinom(2,12,0.1)=0.2301278; dbinom(0,12,0.1)=0.2824295; 1-dbinom(1,12"/>
-          <p:cNvPicPr>
-            <a:picLocks noChangeAspect="1"/>
-          </p:cNvPicPr>
-          <p:nvPr/>
-        </p:nvPicPr>
-        <p:blipFill>
-          <a:blip r:embed="rId8">
-            <a:extLst>
-              <a:ext uri="{28A0092B-C50C-407E-A947-70E740481C1C}">
-                <a14:useLocalDpi xmlns:a14="http://schemas.microsoft.com/office/drawing/2010/main" val="0"/>
-              </a:ext>
-            </a:extLst>
-          </a:blip>
-          <a:srcRect/>
-          <a:stretch>
-            <a:fillRect/>
-          </a:stretch>
-        </p:blipFill>
-        <p:spPr bwMode="auto">
-          <a:xfrm>
-            <a:off x="3429000" y="3883025"/>
-            <a:ext cx="5092700" cy="1917700"/>
-          </a:xfrm>
-          <a:prstGeom prst="rect">
-            <a:avLst/>
-          </a:prstGeom>
-          <a:noFill/>
-          <a:ln>
-            <a:noFill/>
-          </a:ln>
-          <a:extLst>
-            <a:ext uri="{909E8E84-426E-40DD-AFC4-6F175D3DCCD1}">
-              <a14:hiddenFill xmlns:a14="http://schemas.microsoft.com/office/drawing/2010/main">
-                <a:solidFill>
-                  <a:srgbClr val="FFFFFF"/>
-                </a:solidFill>
-              </a14:hiddenFill>
-            </a:ext>
-            <a:ext uri="{91240B29-F687-4F45-9708-019B960494DF}">
-              <a14:hiddenLine xmlns:a14="http://schemas.microsoft.com/office/drawing/2010/main" w="9525">
-                <a:solidFill>
-                  <a:srgbClr val="000000"/>
-                </a:solidFill>
-                <a:miter lim="800000"/>
-                <a:headEnd/>
-                <a:tailEnd/>
-              </a14:hiddenLine>
-            </a:ext>
-          </a:extLst>
-        </p:spPr>
-      </p:pic>
       <p:sp>
         <p:nvSpPr>
           <p:cNvPr id="159749" name="TextBox 159748"/>
@@ -10087,6 +9979,140 @@
                 <a:latin typeface="Cambria"/>
               </a:rPr>
               <a:t> = 0.2824</a:t>
+            </a:r>
+          </a:p>
+        </p:txBody>
+      </p:sp>
+      <p:sp>
+        <p:nvSpPr>
+          <p:cNvPr id="159751" name="TextBox 159750"/>
+          <p:cNvSpPr txBox="1"/>
+          <p:nvPr/>
+        </p:nvSpPr>
+        <p:spPr>
+          <a:xfrm>
+            <a:off x="3429000" y="3883025"/>
+            <a:ext cx="5092700" cy="1917700"/>
+          </a:xfrm>
+          <a:prstGeom prst="rect">
+            <a:avLst/>
+          </a:prstGeom>
+          <a:noFill/>
+        </p:spPr>
+        <p:txBody>
+          <a:bodyPr wrap="none" anchor="t" lIns="0" rIns="0" tIns="0" bIns="0">
+            <a:spAutoFit/>
+          </a:bodyPr>
+          <a:lstStyle/>
+          <a:p>
+            <a:r>
+              <a:rPr sz="1700">
+                <a:solidFill>
+                  <a:srgbClr val="0000FF"/>
+                </a:solidFill>
+                <a:latin typeface="Consolas"/>
+              </a:rPr>
+              <a:t>&gt; dbinom(2,12,0.1)</a:t>
+            </a:r>
+          </a:p>
+          <a:p>
+            <a:r>
+              <a:rPr sz="1700">
+                <a:solidFill>
+                  <a:srgbClr val="000000"/>
+                </a:solidFill>
+                <a:latin typeface="Consolas"/>
+              </a:rPr>
+              <a:t>[1] 0.2301278</a:t>
+            </a:r>
+          </a:p>
+          <a:p>
+            <a:r>
+              <a:rPr sz="1700">
+                <a:solidFill>
+                  <a:srgbClr val="0000FF"/>
+                </a:solidFill>
+                <a:latin typeface="Consolas"/>
+              </a:rPr>
+              <a:t>&gt; dbinom(0,12,0.1)</a:t>
+            </a:r>
+          </a:p>
+          <a:p>
+            <a:r>
+              <a:rPr sz="1700">
+                <a:solidFill>
+                  <a:srgbClr val="000000"/>
+                </a:solidFill>
+                <a:latin typeface="Consolas"/>
+              </a:rPr>
+              <a:t>[1] 0.2824295</a:t>
+            </a:r>
+          </a:p>
+          <a:p>
+            <a:r>
+              <a:rPr sz="1700">
+                <a:solidFill>
+                  <a:srgbClr val="0000FF"/>
+                </a:solidFill>
+                <a:latin typeface="Consolas"/>
+              </a:rPr>
+              <a:t>&gt; 1-dbinom(1,12,0.1)-dbinom(0,12,0.1)</a:t>
+            </a:r>
+          </a:p>
+          <a:p>
+            <a:r>
+              <a:rPr sz="1700">
+                <a:solidFill>
+                  <a:srgbClr val="000000"/>
+                </a:solidFill>
+                <a:latin typeface="Consolas"/>
+              </a:rPr>
+              <a:t>[1] 0.3409977</a:t>
+            </a:r>
+          </a:p>
+        </p:txBody>
+      </p:sp>
+      <p:sp>
+        <p:nvSpPr>
+          <p:cNvPr id="159752" name="TextBox 159751"/>
+          <p:cNvSpPr txBox="1"/>
+          <p:nvPr/>
+        </p:nvSpPr>
+        <p:spPr>
+          <a:xfrm>
+            <a:off x="4038600" y="6029325"/>
+            <a:ext cx="2786888" cy="609600"/>
+          </a:xfrm>
+          <a:prstGeom prst="rect">
+            <a:avLst/>
+          </a:prstGeom>
+          <a:noFill/>
+        </p:spPr>
+        <p:txBody>
+          <a:bodyPr wrap="none" anchor="t" lIns="0" rIns="0" tIns="0" bIns="0">
+            <a:spAutoFit/>
+          </a:bodyPr>
+          <a:lstStyle/>
+          <a:p>
+            <a:r>
+              <a:rPr sz="1700">
+                <a:solidFill>
+                  <a:srgbClr val="0000FF"/>
+                </a:solidFill>
+                <a:latin typeface="Consolas"/>
+              </a:rPr>
+              <a:t>&gt; 1-pbinom(1,12,0.1)</a:t>
+            </a:r>
+          </a:p>
+          <a:p>
+            <a:r>
+              <a:rPr sz="1700">
+                <a:solidFill>
+                  <a:srgbClr val="000000"/>
+                </a:solidFill>
+                <a:latin typeface="Consolas"/>
+              </a:rPr>
+              <a:t>[1] 0.3409977</a:t>
             </a:r>
           </a:p>
         </p:txBody>
@@ -13454,30 +13480,6 @@
           </a:p>
         </p:txBody>
       </p:sp>
-      <p:pic>
-        <p:nvPicPr>
-          <p:cNvPr id="5" name="Picture 4" descr="Multinomial distribution text and formula. Equation: Pr{k | N, p} = N! / (product over i of k_i!) times product over i=1 to n of p_i^(k_i). Extends the binomial to n outcome categories." title="Multinomial distribution text and formula. Equation: Pr{k | N, p} = N! / (produc"/>
-          <p:cNvPicPr>
-            <a:picLocks noChangeAspect="1"/>
-          </p:cNvPicPr>
-          <p:nvPr/>
-        </p:nvPicPr>
-        <p:blipFill>
-          <a:blip r:embed="rId2"/>
-          <a:stretch>
-            <a:fillRect/>
-          </a:stretch>
-        </p:blipFill>
-        <p:spPr>
-          <a:xfrm>
-            <a:off x="0" y="0"/>
-            <a:ext cx="11378756" cy="6631029"/>
-          </a:xfrm>
-          <a:prstGeom prst="rect">
-            <a:avLst/>
-          </a:prstGeom>
-        </p:spPr>
-      </p:pic>
       <p:sp>
         <p:nvSpPr>
           <p:cNvPr id="7" name="TextBox 6"/>
@@ -13588,6 +13590,184 @@
                 <a:latin typeface="Cambria"/>
               </a:rPr>
               <a:t>xₖ</a:t>
+            </a:r>
+          </a:p>
+        </p:txBody>
+      </p:sp>
+      <p:sp>
+        <p:nvSpPr>
+          <p:cNvPr id="9" name="TextBox 8"/>
+          <p:cNvSpPr txBox="1"/>
+          <p:nvPr/>
+        </p:nvSpPr>
+        <p:spPr>
+          <a:xfrm>
+            <a:off x="164592" y="164592"/>
+            <a:ext cx="11049572" cy="534924"/>
+          </a:xfrm>
+          <a:prstGeom prst="rect">
+            <a:avLst/>
+          </a:prstGeom>
+          <a:noFill/>
+        </p:spPr>
+        <p:txBody>
+          <a:bodyPr wrap="square" anchor="t" lIns="0" rIns="0" tIns="0" bIns="0">
+            <a:spAutoFit/>
+          </a:bodyPr>
+          <a:lstStyle/>
+          <a:p>
+            <a:r>
+              <a:rPr sz="2800" b="1">
+                <a:latin typeface="Calibri"/>
+              </a:rPr>
+              <a:t>The multinomial distribution: more than one kind of success</a:t>
+            </a:r>
+          </a:p>
+        </p:txBody>
+      </p:sp>
+      <p:sp>
+        <p:nvSpPr>
+          <p:cNvPr id="10" name="TextBox 9"/>
+          <p:cNvSpPr txBox="1"/>
+          <p:nvPr/>
+        </p:nvSpPr>
+        <p:spPr>
+          <a:xfrm>
+            <a:off x="164592" y="973836"/>
+            <a:ext cx="11049572" cy="1683639"/>
+          </a:xfrm>
+          <a:prstGeom prst="rect">
+            <a:avLst/>
+          </a:prstGeom>
+          <a:noFill/>
+        </p:spPr>
+        <p:txBody>
+          <a:bodyPr wrap="square" anchor="t" lIns="0" rIns="0" tIns="0" bIns="0">
+            <a:spAutoFit/>
+          </a:bodyPr>
+          <a:lstStyle/>
+          <a:p>
+            <a:r>
+              <a:rPr sz="1900" b="0">
+                <a:latin typeface="Calibri"/>
+              </a:rPr>
+              <a:t>The multinomial distribution is an extension of the binomial distribution to the case of more than two (we shall assume n) kinds of outcomes, in which a single trial has probability p</a:t>
+            </a:r>
+            <a:r>
+              <a:rPr sz="1900" b="0" baseline="-25000">
+                <a:latin typeface="Calibri"/>
+              </a:rPr>
+              <a:t>i</a:t>
+            </a:r>
+            <a:r>
+              <a:rPr sz="1900" b="0">
+                <a:latin typeface="Calibri"/>
+              </a:rPr>
+              <a:t> of ending in category i. In a total of N trials, we assume that k</a:t>
+            </a:r>
+            <a:r>
+              <a:rPr sz="1900" b="0" baseline="-25000">
+                <a:latin typeface="Calibri"/>
+              </a:rPr>
+              <a:t>i</a:t>
+            </a:r>
+            <a:r>
+              <a:rPr sz="1900" b="0">
+                <a:latin typeface="Calibri"/>
+              </a:rPr>
+              <a:t> of the outcomes end in category i. If we let p denote the vector of the different probabilities of outcome and k denote the vector of the data, the probability distribution is then an extension of the binomial distribution</a:t>
+            </a:r>
+          </a:p>
+        </p:txBody>
+      </p:sp>
+      <p:sp>
+        <p:nvSpPr>
+          <p:cNvPr id="11" name="TextBox 10"/>
+          <p:cNvSpPr txBox="1"/>
+          <p:nvPr/>
+        </p:nvSpPr>
+        <p:spPr>
+          <a:xfrm>
+            <a:off x="164592" y="2968371"/>
+            <a:ext cx="11049572" cy="397764"/>
+          </a:xfrm>
+          <a:prstGeom prst="rect">
+            <a:avLst/>
+          </a:prstGeom>
+          <a:noFill/>
+        </p:spPr>
+        <p:txBody>
+          <a:bodyPr wrap="square" anchor="t" lIns="0" rIns="0" tIns="0" bIns="0">
+            <a:spAutoFit/>
+          </a:bodyPr>
+          <a:lstStyle/>
+          <a:p>
+            <a:pPr algn="ctr"/>
+            <a:r>
+              <a:rPr sz="2000" b="0">
+                <a:latin typeface="Cambria"/>
+              </a:rPr>
+              <a:t>Pr{k | N, p} = N! / (∏</a:t>
+            </a:r>
+            <a:r>
+              <a:rPr sz="2000" b="0" baseline="-25000">
+                <a:latin typeface="Cambria"/>
+              </a:rPr>
+              <a:t>i=1</a:t>
+            </a:r>
+            <a:r>
+              <a:rPr sz="2000" b="0" baseline="30000">
+                <a:latin typeface="Cambria"/>
+              </a:rPr>
+              <a:t>n</a:t>
+            </a:r>
+            <a:r>
+              <a:rPr sz="2000" b="0">
+                <a:latin typeface="Cambria"/>
+              </a:rPr>
+              <a:t> k</a:t>
+            </a:r>
+            <a:r>
+              <a:rPr sz="2000" b="0" baseline="-25000">
+                <a:latin typeface="Cambria"/>
+              </a:rPr>
+              <a:t>i</a:t>
+            </a:r>
+            <a:r>
+              <a:rPr sz="2000" b="0">
+                <a:latin typeface="Cambria"/>
+              </a:rPr>
+              <a:t>!) · ∏</a:t>
+            </a:r>
+            <a:r>
+              <a:rPr sz="2000" b="0" baseline="-25000">
+                <a:latin typeface="Cambria"/>
+              </a:rPr>
+              <a:t>i=1</a:t>
+            </a:r>
+            <a:r>
+              <a:rPr sz="2000" b="0" baseline="30000">
+                <a:latin typeface="Cambria"/>
+              </a:rPr>
+              <a:t>n</a:t>
+            </a:r>
+            <a:r>
+              <a:rPr sz="2000" b="0">
+                <a:latin typeface="Cambria"/>
+              </a:rPr>
+              <a:t> p</a:t>
+            </a:r>
+            <a:r>
+              <a:rPr sz="2000" b="0" baseline="-25000">
+                <a:latin typeface="Cambria"/>
+              </a:rPr>
+              <a:t>i</a:t>
+            </a:r>
+            <a:r>
+              <a:rPr sz="2000" b="0" baseline="30000">
+                <a:latin typeface="Cambria"/>
+              </a:rPr>
+              <a:t>kᵢ</a:t>
             </a:r>
           </a:p>
         </p:txBody>
@@ -19017,60 +19197,6 @@
           </a:p>
         </p:txBody>
       </p:sp>
-      <p:pic>
-        <p:nvPicPr>
-          <p:cNvPr id="2" name="Picture 1" descr="R console: dpois(4,3) returns 0.1680314, the Poisson probability of exactly 4 events when the mean is 3." title="R console: dpois(4,3) returns 0.1680314, the Poisson probability of exactly 4 ev"/>
-          <p:cNvPicPr>
-            <a:picLocks noChangeAspect="1"/>
-          </p:cNvPicPr>
-          <p:nvPr/>
-        </p:nvPicPr>
-        <p:blipFill>
-          <a:blip r:embed="rId5">
-            <a:extLst>
-              <a:ext uri="{28A0092B-C50C-407E-A947-70E740481C1C}">
-                <a14:useLocalDpi xmlns:a14="http://schemas.microsoft.com/office/drawing/2010/main" val="0"/>
-              </a:ext>
-            </a:extLst>
-          </a:blip>
-          <a:srcRect/>
-          <a:stretch>
-            <a:fillRect/>
-          </a:stretch>
-        </p:blipFill>
-        <p:spPr bwMode="auto">
-          <a:xfrm>
-            <a:off x="4800601" y="5246496"/>
-            <a:ext cx="2341563" cy="774700"/>
-          </a:xfrm>
-          <a:prstGeom prst="rect">
-            <a:avLst/>
-          </a:prstGeom>
-          <a:noFill/>
-          <a:ln>
-            <a:noFill/>
-          </a:ln>
-          <a:extLst>
-            <a:ext uri="{909E8E84-426E-40DD-AFC4-6F175D3DCCD1}">
-              <a14:hiddenFill xmlns:a14="http://schemas.microsoft.com/office/drawing/2010/main">
-                <a:solidFill>
-                  <a:srgbClr val="FFFFFF"/>
-                </a:solidFill>
-              </a14:hiddenFill>
-            </a:ext>
-            <a:ext uri="{91240B29-F687-4F45-9708-019B960494DF}">
-              <a14:hiddenLine xmlns:a14="http://schemas.microsoft.com/office/drawing/2010/main" w="9525">
-                <a:solidFill>
-                  <a:srgbClr val="000000"/>
-                </a:solidFill>
-                <a:miter lim="800000"/>
-                <a:headEnd/>
-                <a:tailEnd/>
-              </a14:hiddenLine>
-            </a:ext>
-          </a:extLst>
-        </p:spPr>
-      </p:pic>
       <p:sp>
         <p:nvSpPr>
           <p:cNvPr id="7172" name="TextBox 7171"/>
@@ -19146,6 +19272,51 @@
                 <a:latin typeface="Cambria"/>
               </a:rPr>
               <a:t> / 4! = 0.168</a:t>
+            </a:r>
+          </a:p>
+        </p:txBody>
+      </p:sp>
+      <p:sp>
+        <p:nvSpPr>
+          <p:cNvPr id="7173" name="TextBox 7172"/>
+          <p:cNvSpPr txBox="1"/>
+          <p:nvPr/>
+        </p:nvSpPr>
+        <p:spPr>
+          <a:xfrm>
+            <a:off x="4800601" y="5246496"/>
+            <a:ext cx="2341563" cy="774700"/>
+          </a:xfrm>
+          <a:prstGeom prst="rect">
+            <a:avLst/>
+          </a:prstGeom>
+          <a:noFill/>
+        </p:spPr>
+        <p:txBody>
+          <a:bodyPr wrap="none" anchor="t" lIns="0" rIns="0" tIns="0" bIns="0">
+            <a:spAutoFit/>
+          </a:bodyPr>
+          <a:lstStyle/>
+          <a:p>
+            <a:r>
+              <a:rPr sz="2000">
+                <a:solidFill>
+                  <a:srgbClr val="0000FF"/>
+                </a:solidFill>
+                <a:latin typeface="Consolas"/>
+              </a:rPr>
+              <a:t>&gt; dpois(4,3)</a:t>
+            </a:r>
+          </a:p>
+          <a:p>
+            <a:r>
+              <a:rPr sz="2000">
+                <a:solidFill>
+                  <a:srgbClr val="000000"/>
+                </a:solidFill>
+                <a:latin typeface="Consolas"/>
+              </a:rPr>
+              <a:t>[1] 0.1680314</a:t>
             </a:r>
           </a:p>
         </p:txBody>
@@ -19405,60 +19576,6 @@
           </a:p>
         </p:txBody>
       </p:sp>
-      <p:pic>
-        <p:nvPicPr>
-          <p:cNvPr id="2" name="Picture 1" descr="R console: dpois(0,3)+dpois(1,3)+dpois(2,3)=0.4231901 and ppois(2,3)=0.4231901, the Poisson probability of 2 or fewer events when the mean is 3." title="R console: dpois(0,3)+dpois(1,3)+dpois(2,3)=0.4231901 and ppois(2,3)=0.4231901, "/>
-          <p:cNvPicPr>
-            <a:picLocks noChangeAspect="1"/>
-          </p:cNvPicPr>
-          <p:nvPr/>
-        </p:nvPicPr>
-        <p:blipFill>
-          <a:blip r:embed="rId5">
-            <a:extLst>
-              <a:ext uri="{28A0092B-C50C-407E-A947-70E740481C1C}">
-                <a14:useLocalDpi xmlns:a14="http://schemas.microsoft.com/office/drawing/2010/main" val="0"/>
-              </a:ext>
-            </a:extLst>
-          </a:blip>
-          <a:srcRect/>
-          <a:stretch>
-            <a:fillRect/>
-          </a:stretch>
-        </p:blipFill>
-        <p:spPr bwMode="auto">
-          <a:xfrm>
-            <a:off x="6113463" y="5114925"/>
-            <a:ext cx="4495800" cy="1244600"/>
-          </a:xfrm>
-          <a:prstGeom prst="rect">
-            <a:avLst/>
-          </a:prstGeom>
-          <a:noFill/>
-          <a:ln>
-            <a:noFill/>
-          </a:ln>
-          <a:extLst>
-            <a:ext uri="{909E8E84-426E-40DD-AFC4-6F175D3DCCD1}">
-              <a14:hiddenFill xmlns:a14="http://schemas.microsoft.com/office/drawing/2010/main">
-                <a:solidFill>
-                  <a:srgbClr val="FFFFFF"/>
-                </a:solidFill>
-              </a14:hiddenFill>
-            </a:ext>
-            <a:ext uri="{91240B29-F687-4F45-9708-019B960494DF}">
-              <a14:hiddenLine xmlns:a14="http://schemas.microsoft.com/office/drawing/2010/main" w="9525">
-                <a:solidFill>
-                  <a:srgbClr val="000000"/>
-                </a:solidFill>
-                <a:miter lim="800000"/>
-                <a:headEnd/>
-                <a:tailEnd/>
-              </a14:hiddenLine>
-            </a:ext>
-          </a:extLst>
-        </p:spPr>
-      </p:pic>
       <p:sp>
         <p:nvSpPr>
           <p:cNvPr id="8196" name="TextBox 8195"/>
@@ -19534,6 +19651,73 @@
                 <a:latin typeface="Cambria"/>
               </a:rPr>
               <a:t>/2! ] = 0.423</a:t>
+            </a:r>
+          </a:p>
+        </p:txBody>
+      </p:sp>
+      <p:sp>
+        <p:nvSpPr>
+          <p:cNvPr id="8197" name="TextBox 8196"/>
+          <p:cNvSpPr txBox="1"/>
+          <p:nvPr/>
+        </p:nvSpPr>
+        <p:spPr>
+          <a:xfrm>
+            <a:off x="6113463" y="5114925"/>
+            <a:ext cx="4495800" cy="1244600"/>
+          </a:xfrm>
+          <a:prstGeom prst="rect">
+            <a:avLst/>
+          </a:prstGeom>
+          <a:noFill/>
+        </p:spPr>
+        <p:txBody>
+          <a:bodyPr wrap="none" anchor="t" lIns="0" rIns="0" tIns="0" bIns="0">
+            <a:spAutoFit/>
+          </a:bodyPr>
+          <a:lstStyle/>
+          <a:p>
+            <a:r>
+              <a:rPr sz="1600">
+                <a:solidFill>
+                  <a:srgbClr val="0000FF"/>
+                </a:solidFill>
+                <a:latin typeface="Consolas"/>
+              </a:rPr>
+              <a:t>&gt; dpois(0,3)+dpois(1,3)+dpois(2,3)</a:t>
+            </a:r>
+          </a:p>
+          <a:p>
+            <a:r>
+              <a:rPr sz="1600">
+                <a:solidFill>
+                  <a:srgbClr val="000000"/>
+                </a:solidFill>
+                <a:latin typeface="Consolas"/>
+              </a:rPr>
+              <a:t>[1] 0.4231901</a:t>
+            </a:r>
+          </a:p>
+          <a:p>
+            <a:r>
+              <a:rPr sz="1600">
+                <a:solidFill>
+                  <a:srgbClr val="0000FF"/>
+                </a:solidFill>
+                <a:latin typeface="Consolas"/>
+              </a:rPr>
+              <a:t>&gt; ppois(2,3)</a:t>
+            </a:r>
+          </a:p>
+          <a:p>
+            <a:r>
+              <a:rPr sz="1600">
+                <a:solidFill>
+                  <a:srgbClr val="000000"/>
+                </a:solidFill>
+                <a:latin typeface="Consolas"/>
+              </a:rPr>
+              <a:t>[1] 0.4231901</a:t>
             </a:r>
           </a:p>
         </p:txBody>
@@ -19836,30 +20020,6 @@
           </a:p>
         </p:txBody>
       </p:sp>
-      <p:pic>
-        <p:nvPicPr>
-          <p:cNvPr id="4" name="Picture 3" descr="R console: dpois(0,3)=0.04978707 and 1-dpois(0,3)=0.9502129, the Poisson probability of at least one event when the mean is 3." title="R console: dpois(0,3)=0.04978707 and 1-dpois(0,3)=0.9502129, the Poisson probabi"/>
-          <p:cNvPicPr>
-            <a:picLocks noChangeAspect="1"/>
-          </p:cNvPicPr>
-          <p:nvPr/>
-        </p:nvPicPr>
-        <p:blipFill>
-          <a:blip r:embed="rId3"/>
-          <a:stretch>
-            <a:fillRect/>
-          </a:stretch>
-        </p:blipFill>
-        <p:spPr>
-          <a:xfrm>
-            <a:off x="4501876" y="4392386"/>
-            <a:ext cx="3021012" cy="1883228"/>
-          </a:xfrm>
-          <a:prstGeom prst="rect">
-            <a:avLst/>
-          </a:prstGeom>
-        </p:spPr>
-      </p:pic>
       <p:sp>
         <p:nvSpPr>
           <p:cNvPr id="2" name="TextBox 1"/>
@@ -19998,6 +20158,73 @@
           </a:fontRef>
         </p:style>
       </p:cxnSp>
+      <p:sp>
+        <p:nvSpPr>
+          <p:cNvPr id="8196" name="TextBox 8195"/>
+          <p:cNvSpPr txBox="1"/>
+          <p:nvPr/>
+        </p:nvSpPr>
+        <p:spPr>
+          <a:xfrm>
+            <a:off x="4501876" y="4392386"/>
+            <a:ext cx="3021012" cy="1883228"/>
+          </a:xfrm>
+          <a:prstGeom prst="rect">
+            <a:avLst/>
+          </a:prstGeom>
+          <a:noFill/>
+        </p:spPr>
+        <p:txBody>
+          <a:bodyPr wrap="none" anchor="t" lIns="0" rIns="0" tIns="0" bIns="0">
+            <a:spAutoFit/>
+          </a:bodyPr>
+          <a:lstStyle/>
+          <a:p>
+            <a:r>
+              <a:rPr sz="2000">
+                <a:solidFill>
+                  <a:srgbClr val="0000FF"/>
+                </a:solidFill>
+                <a:latin typeface="Consolas"/>
+              </a:rPr>
+              <a:t>&gt; dpois(0,3)</a:t>
+            </a:r>
+          </a:p>
+          <a:p>
+            <a:r>
+              <a:rPr sz="2000">
+                <a:solidFill>
+                  <a:srgbClr val="000000"/>
+                </a:solidFill>
+                <a:latin typeface="Consolas"/>
+              </a:rPr>
+              <a:t>[1] 0.04978707</a:t>
+            </a:r>
+          </a:p>
+          <a:p>
+            <a:r>
+              <a:rPr sz="2000">
+                <a:solidFill>
+                  <a:srgbClr val="0000FF"/>
+                </a:solidFill>
+                <a:latin typeface="Consolas"/>
+              </a:rPr>
+              <a:t>&gt; 1-dpois(0,3)</a:t>
+            </a:r>
+          </a:p>
+          <a:p>
+            <a:r>
+              <a:rPr sz="2000">
+                <a:solidFill>
+                  <a:srgbClr val="000000"/>
+                </a:solidFill>
+                <a:latin typeface="Consolas"/>
+              </a:rPr>
+              <a:t>[1] 0.9502129</a:t>
+            </a:r>
+          </a:p>
+        </p:txBody>
+      </p:sp>
     </p:spTree>
     <p:extLst>
       <p:ext uri="{BB962C8B-B14F-4D97-AF65-F5344CB8AC3E}">
@@ -20060,60 +20287,6 @@
           </a:p>
         </p:txBody>
       </p:sp>
-      <p:pic>
-        <p:nvPicPr>
-          <p:cNvPr id="6" name="Picture 5" descr="Journal excerpt: modeling observed attacks as a Poisson process, the probability of zero attacks being seen before 1990 is 0.006, given a rate constant over the 27-year period." title="Journal excerpt: modeling observed attacks as a Poisson process, the probability"/>
-          <p:cNvPicPr>
-            <a:picLocks noChangeAspect="1"/>
-          </p:cNvPicPr>
-          <p:nvPr/>
-        </p:nvPicPr>
-        <p:blipFill>
-          <a:blip r:embed="rId3">
-            <a:extLst>
-              <a:ext uri="{28A0092B-C50C-407E-A947-70E740481C1C}">
-                <a14:useLocalDpi xmlns:a14="http://schemas.microsoft.com/office/drawing/2010/main" val="0"/>
-              </a:ext>
-            </a:extLst>
-          </a:blip>
-          <a:srcRect/>
-          <a:stretch>
-            <a:fillRect/>
-          </a:stretch>
-        </p:blipFill>
-        <p:spPr bwMode="auto">
-          <a:xfrm>
-            <a:off x="2698750" y="4857687"/>
-            <a:ext cx="6896100" cy="1803400"/>
-          </a:xfrm>
-          <a:prstGeom prst="rect">
-            <a:avLst/>
-          </a:prstGeom>
-          <a:noFill/>
-          <a:ln>
-            <a:noFill/>
-          </a:ln>
-          <a:extLst>
-            <a:ext uri="{909E8E84-426E-40DD-AFC4-6F175D3DCCD1}">
-              <a14:hiddenFill xmlns:a14="http://schemas.microsoft.com/office/drawing/2010/main">
-                <a:solidFill>
-                  <a:srgbClr val="FFFFFF"/>
-                </a:solidFill>
-              </a14:hiddenFill>
-            </a:ext>
-            <a:ext uri="{91240B29-F687-4F45-9708-019B960494DF}">
-              <a14:hiddenLine xmlns:a14="http://schemas.microsoft.com/office/drawing/2010/main" w="9525">
-                <a:solidFill>
-                  <a:srgbClr val="000000"/>
-                </a:solidFill>
-                <a:miter lim="800000"/>
-                <a:headEnd/>
-                <a:tailEnd/>
-              </a14:hiddenLine>
-            </a:ext>
-          </a:extLst>
-        </p:spPr>
-      </p:pic>
       <p:pic>
         <p:nvPicPr>
           <p:cNvPr id="197635" name="Picture 6" descr="Journal article header: 'Killer Whale Predation on Sea Otters Linking Oceanic and Nearshore Ecosystems' by Estes, Tinker, Williams and Doak, with abstract on sea otter decline from killer whale predation." title="Journal article header: 'Killer Whale Predation on Sea Otters Linking Oceanic an"/>
@@ -20168,6 +20341,37 @@
           </a:extLst>
         </p:spPr>
       </p:pic>
+      <p:sp>
+        <p:nvSpPr>
+          <p:cNvPr id="197636" name="TextBox 197635"/>
+          <p:cNvSpPr txBox="1"/>
+          <p:nvPr/>
+        </p:nvSpPr>
+        <p:spPr>
+          <a:xfrm>
+            <a:off x="2863342" y="5022279"/>
+            <a:ext cx="6566916" cy="929259"/>
+          </a:xfrm>
+          <a:prstGeom prst="rect">
+            <a:avLst/>
+          </a:prstGeom>
+          <a:noFill/>
+        </p:spPr>
+        <p:txBody>
+          <a:bodyPr wrap="square" anchor="t" lIns="0" rIns="0" tIns="0" bIns="0">
+            <a:spAutoFit/>
+          </a:bodyPr>
+          <a:lstStyle/>
+          <a:p>
+            <a:r>
+              <a:rPr sz="1700" b="0">
+                <a:latin typeface="Calibri"/>
+              </a:rPr>
+              <a:t>constant over the 27-year period. By modeling the expected number of observed attacks as a Poisson process, the probability of zero attacks being seen before 1990 is 0.006 (15).</a:t>
+            </a:r>
+          </a:p>
+        </p:txBody>
+      </p:sp>
     </p:spTree>
     <p:extLst>
       <p:ext uri="{BB962C8B-B14F-4D97-AF65-F5344CB8AC3E}">

</xml_diff>